<commit_message>
Brand executive decks for Creatrix Empire, Taash, The Ecommerce Boss and BOZ Jewelry
</commit_message>
<xml_diff>
--- a/01-delivered-case-studies/boz-retail-transformation/Deck/Executive_Deck.pptx
+++ b/01-delivered-case-studies/boz-retail-transformation/Deck/Executive_Deck.pptx
@@ -1391,7 +1391,7 @@
     <p:bg>
       <p:bgPr>
         <a:solidFill>
-          <a:srgbClr val="15253D"/>
+          <a:srgbClr val="FFFFFF"/>
         </a:solidFill>
       </p:bgPr>
     </p:bg>
@@ -1436,7 +1436,7 @@
             <a:r>
               <a:rPr lang="en-US" sz="1300" b="1" spc="200" kern="0" dirty="0">
                 <a:solidFill>
-                  <a:srgbClr val="5EEAD4"/>
+                  <a:srgbClr val="9C7625"/>
                 </a:solidFill>
                 <a:latin typeface="Arial" pitchFamily="34" charset="0"/>
                 <a:ea typeface="Arial" pitchFamily="34" charset="-122"/>
@@ -1457,7 +1457,7 @@
         <p:spPr>
           <a:xfrm>
             <a:off x="731520" y="1645920"/>
-            <a:ext cx="10515600" cy="1463040"/>
+            <a:ext cx="7620000" cy="1463040"/>
           </a:xfrm>
           <a:prstGeom prst="rect">
             <a:avLst/>
@@ -1475,51 +1475,51 @@
             <a:r>
               <a:rPr lang="en-US" sz="4000" b="1" dirty="0">
                 <a:solidFill>
-                  <a:srgbClr val="FFFFFF"/>
+                  <a:srgbClr val="3A2A12"/>
+                </a:solidFill>
+                <a:latin typeface="Liberation Serif" pitchFamily="34" charset="0"/>
+                <a:ea typeface="Liberation Serif" pitchFamily="34" charset="-122"/>
+                <a:cs typeface="Liberation Serif" pitchFamily="34" charset="-120"/>
+              </a:rPr>
+              <a:t>BOZ Jewelry Retail and E-commerce Transformation</a:t>
+            </a:r>
+            <a:endParaRPr lang="en-US" sz="4000" dirty="0"/>
+          </a:p>
+        </p:txBody>
+      </p:sp>
+      <p:sp>
+        <p:nvSpPr>
+          <p:cNvPr id="4" name="Text 2"/>
+          <p:cNvSpPr txBox="1"/>
+          <p:nvPr/>
+        </p:nvSpPr>
+        <p:spPr>
+          <a:xfrm>
+            <a:off x="731520" y="3291840"/>
+            <a:ext cx="10058400" cy="822960"/>
+          </a:xfrm>
+          <a:prstGeom prst="rect">
+            <a:avLst/>
+          </a:prstGeom>
+          <a:noFill/>
+          <a:ln/>
+        </p:spPr>
+        <p:txBody>
+          <a:bodyPr wrap="square" lIns="0" tIns="0" rIns="0" bIns="0" rtlCol="0" anchor="t"/>
+          <a:lstStyle/>
+          <a:p>
+            <a:pPr indent="0" marL="0">
+              <a:buNone/>
+            </a:pPr>
+            <a:r>
+              <a:rPr lang="en-US" sz="1800" dirty="0">
+                <a:solidFill>
+                  <a:srgbClr val="4B5563"/>
                 </a:solidFill>
                 <a:latin typeface="Arial" pitchFamily="34" charset="0"/>
                 <a:ea typeface="Arial" pitchFamily="34" charset="-122"/>
                 <a:cs typeface="Arial" pitchFamily="34" charset="-120"/>
               </a:rPr>
-              <a:t>BOZ Jewelry Retail and E-commerce Transformation</a:t>
-            </a:r>
-            <a:endParaRPr lang="en-US" sz="4000" dirty="0"/>
-          </a:p>
-        </p:txBody>
-      </p:sp>
-      <p:sp>
-        <p:nvSpPr>
-          <p:cNvPr id="4" name="Text 2"/>
-          <p:cNvSpPr txBox="1"/>
-          <p:nvPr/>
-        </p:nvSpPr>
-        <p:spPr>
-          <a:xfrm>
-            <a:off x="731520" y="3291840"/>
-            <a:ext cx="10058400" cy="822960"/>
-          </a:xfrm>
-          <a:prstGeom prst="rect">
-            <a:avLst/>
-          </a:prstGeom>
-          <a:noFill/>
-          <a:ln/>
-        </p:spPr>
-        <p:txBody>
-          <a:bodyPr wrap="square" lIns="0" tIns="0" rIns="0" bIns="0" rtlCol="0" anchor="t"/>
-          <a:lstStyle/>
-          <a:p>
-            <a:pPr indent="0" marL="0">
-              <a:buNone/>
-            </a:pPr>
-            <a:r>
-              <a:rPr lang="en-US" sz="1800" dirty="0">
-                <a:solidFill>
-                  <a:srgbClr val="CBD5E1"/>
-                </a:solidFill>
-                <a:latin typeface="Arial" pitchFamily="34" charset="0"/>
-                <a:ea typeface="Arial" pitchFamily="34" charset="-122"/>
-                <a:cs typeface="Arial" pitchFamily="34" charset="-120"/>
-              </a:rPr>
               <a:t>Retail service redesign connecting customer enquiries, custom orders and internal delivery visibility</a:t>
             </a:r>
             <a:endParaRPr lang="en-US" sz="1800" dirty="0"/>
@@ -1543,11 +1543,15 @@
           <a:noFill/>
           <a:ln w="25400">
             <a:solidFill>
-              <a:srgbClr val="5EEAD4"/>
+              <a:srgbClr val="9C7625"/>
             </a:solidFill>
             <a:prstDash val="solid"/>
           </a:ln>
         </p:spPr>
+        <p:txBody>
+          <a:bodyPr/>
+          <a:p/>
+        </p:txBody>
       </p:sp>
       <p:sp>
         <p:nvSpPr>
@@ -1579,7 +1583,7 @@
             <a:r>
               <a:rPr lang="en-US" sz="1400" b="1" dirty="0">
                 <a:solidFill>
-                  <a:srgbClr val="E2E8F0"/>
+                  <a:srgbClr val="1F2937"/>
                 </a:solidFill>
                 <a:latin typeface="Arial" pitchFamily="34" charset="0"/>
                 <a:ea typeface="Arial" pitchFamily="34" charset="-122"/>
@@ -1596,7 +1600,7 @@
             <a:r>
               <a:rPr lang="en-US" sz="1400" dirty="0">
                 <a:solidFill>
-                  <a:srgbClr val="E2E8F0"/>
+                  <a:srgbClr val="1F2937"/>
                 </a:solidFill>
                 <a:latin typeface="Arial" pitchFamily="34" charset="0"/>
                 <a:ea typeface="Arial" pitchFamily="34" charset="-122"/>
@@ -1616,7 +1620,7 @@
             <a:r>
               <a:rPr lang="en-US" sz="1400" b="1" dirty="0">
                 <a:solidFill>
-                  <a:srgbClr val="E2E8F0"/>
+                  <a:srgbClr val="1F2937"/>
                 </a:solidFill>
                 <a:latin typeface="Arial" pitchFamily="34" charset="0"/>
                 <a:ea typeface="Arial" pitchFamily="34" charset="-122"/>
@@ -1633,7 +1637,7 @@
             <a:r>
               <a:rPr lang="en-US" sz="1400" dirty="0">
                 <a:solidFill>
-                  <a:srgbClr val="E2E8F0"/>
+                  <a:srgbClr val="1F2937"/>
                 </a:solidFill>
                 <a:latin typeface="Arial" pitchFamily="34" charset="0"/>
                 <a:ea typeface="Arial" pitchFamily="34" charset="-122"/>
@@ -1653,7 +1657,7 @@
             <a:r>
               <a:rPr lang="en-US" sz="1400" b="1" dirty="0">
                 <a:solidFill>
-                  <a:srgbClr val="E2E8F0"/>
+                  <a:srgbClr val="1F2937"/>
                 </a:solidFill>
                 <a:latin typeface="Arial" pitchFamily="34" charset="0"/>
                 <a:ea typeface="Arial" pitchFamily="34" charset="-122"/>
@@ -1670,7 +1674,7 @@
             <a:r>
               <a:rPr lang="en-US" sz="1400" dirty="0">
                 <a:solidFill>
-                  <a:srgbClr val="E2E8F0"/>
+                  <a:srgbClr val="1F2937"/>
                 </a:solidFill>
                 <a:latin typeface="Arial" pitchFamily="34" charset="0"/>
                 <a:ea typeface="Arial" pitchFamily="34" charset="-122"/>
@@ -1679,6 +1683,129 @@
               <a:t>IT Project Manager, E-commerce and Digital Systems</a:t>
             </a:r>
             <a:endParaRPr lang="en-US" sz="1400" dirty="0"/>
+          </a:p>
+        </p:txBody>
+      </p:sp>
+      <p:sp>
+        <p:nvSpPr>
+          <p:cNvPr id="7" name="Rectangle 6"/>
+          <p:cNvSpPr/>
+          <p:nvPr/>
+        </p:nvSpPr>
+        <p:spPr>
+          <a:xfrm>
+            <a:off x="0" y="0"/>
+            <a:ext cx="320040" cy="6858000"/>
+          </a:xfrm>
+          <a:prstGeom prst="rect">
+            <a:avLst/>
+          </a:prstGeom>
+          <a:solidFill>
+            <a:srgbClr val="3A2A12"/>
+          </a:solidFill>
+          <a:ln>
+            <a:noFill/>
+          </a:ln>
+          <a:effectLst/>
+        </p:spPr>
+        <p:style>
+          <a:lnRef idx="1">
+            <a:schemeClr val="accent1"/>
+          </a:lnRef>
+          <a:fillRef idx="3">
+            <a:schemeClr val="accent1"/>
+          </a:fillRef>
+          <a:effectRef idx="2">
+            <a:schemeClr val="accent1"/>
+          </a:effectRef>
+          <a:fontRef idx="minor">
+            <a:schemeClr val="lt1"/>
+          </a:fontRef>
+        </p:style>
+        <p:txBody>
+          <a:bodyPr rtlCol="0" anchor="ctr"/>
+          <a:lstStyle/>
+          <a:p>
+            <a:pPr algn="ctr"/>
+          </a:p>
+        </p:txBody>
+      </p:sp>
+      <p:sp>
+        <p:nvSpPr>
+          <p:cNvPr id="8" name="Rectangle 7"/>
+          <p:cNvSpPr/>
+          <p:nvPr/>
+        </p:nvSpPr>
+        <p:spPr>
+          <a:xfrm>
+            <a:off x="320040" y="0"/>
+            <a:ext cx="73152" cy="6858000"/>
+          </a:xfrm>
+          <a:prstGeom prst="rect">
+            <a:avLst/>
+          </a:prstGeom>
+          <a:solidFill>
+            <a:srgbClr val="C9A24A"/>
+          </a:solidFill>
+          <a:ln>
+            <a:noFill/>
+          </a:ln>
+          <a:effectLst/>
+        </p:spPr>
+        <p:style>
+          <a:lnRef idx="1">
+            <a:schemeClr val="accent1"/>
+          </a:lnRef>
+          <a:fillRef idx="3">
+            <a:schemeClr val="accent1"/>
+          </a:fillRef>
+          <a:effectRef idx="2">
+            <a:schemeClr val="accent1"/>
+          </a:effectRef>
+          <a:fontRef idx="minor">
+            <a:schemeClr val="lt1"/>
+          </a:fontRef>
+        </p:style>
+        <p:txBody>
+          <a:bodyPr rtlCol="0" anchor="ctr"/>
+          <a:lstStyle/>
+          <a:p>
+            <a:pPr algn="ctr"/>
+          </a:p>
+        </p:txBody>
+      </p:sp>
+      <p:sp>
+        <p:nvSpPr>
+          <p:cNvPr id="9" name="TextBox 8"/>
+          <p:cNvSpPr txBox="1"/>
+          <p:nvPr/>
+        </p:nvSpPr>
+        <p:spPr>
+          <a:xfrm>
+            <a:off x="8442961" y="640080"/>
+            <a:ext cx="3108960" cy="1463040"/>
+          </a:xfrm>
+          <a:prstGeom prst="rect">
+            <a:avLst/>
+          </a:prstGeom>
+          <a:noFill/>
+        </p:spPr>
+        <p:txBody>
+          <a:bodyPr wrap="none" anchor="ctr">
+            <a:spAutoFit/>
+          </a:bodyPr>
+          <a:lstStyle/>
+          <a:p>
+            <a:pPr algn="ctr"/>
+            <a:r>
+              <a:rPr sz="6000" b="1">
+                <a:solidFill>
+                  <a:srgbClr val="C9A24A"/>
+                </a:solidFill>
+                <a:latin typeface="Liberation Serif"/>
+              </a:rPr>
+              <a:t>BOZ</a:t>
+            </a:r>
           </a:p>
         </p:txBody>
       </p:sp>
@@ -1741,53 +1868,242 @@
             <a:r>
               <a:rPr lang="en-US" sz="2600" b="1" dirty="0">
                 <a:solidFill>
-                  <a:srgbClr val="15253D"/>
+                  <a:srgbClr val="3A2A12"/>
+                </a:solidFill>
+                <a:latin typeface="Liberation Serif" pitchFamily="34" charset="0"/>
+                <a:ea typeface="Liberation Serif" pitchFamily="34" charset="-122"/>
+                <a:cs typeface="Liberation Serif" pitchFamily="34" charset="-120"/>
+              </a:rPr>
+              <a:t>The problem and what discovery found</a:t>
+            </a:r>
+            <a:endParaRPr lang="en-US" sz="2600" dirty="0"/>
+          </a:p>
+        </p:txBody>
+      </p:sp>
+      <p:sp>
+        <p:nvSpPr>
+          <p:cNvPr id="3" name="Shape 1"/>
+          <p:cNvSpPr/>
+          <p:nvPr/>
+        </p:nvSpPr>
+        <p:spPr>
+          <a:xfrm>
+            <a:off x="457200" y="1463040"/>
+            <a:ext cx="5120640" cy="4480560"/>
+          </a:xfrm>
+          <a:prstGeom prst="rect">
+            <a:avLst/>
+          </a:prstGeom>
+          <a:solidFill>
+            <a:srgbClr val="FBF8F1"/>
+          </a:solidFill>
+          <a:ln w="12700">
+            <a:solidFill>
+              <a:srgbClr val="FBF8F1"/>
+            </a:solidFill>
+            <a:prstDash val="solid"/>
+          </a:ln>
+        </p:spPr>
+        <p:txBody>
+          <a:bodyPr/>
+          <a:p/>
+        </p:txBody>
+      </p:sp>
+      <p:sp>
+        <p:nvSpPr>
+          <p:cNvPr id="4" name="Text 2"/>
+          <p:cNvSpPr txBox="1"/>
+          <p:nvPr/>
+        </p:nvSpPr>
+        <p:spPr>
+          <a:xfrm>
+            <a:off x="731520" y="1691640"/>
+            <a:ext cx="4572000" cy="365760"/>
+          </a:xfrm>
+          <a:prstGeom prst="rect">
+            <a:avLst/>
+          </a:prstGeom>
+          <a:noFill/>
+          <a:ln/>
+        </p:spPr>
+        <p:txBody>
+          <a:bodyPr wrap="square" lIns="0" tIns="0" rIns="0" bIns="0" rtlCol="0" anchor="ctr"/>
+          <a:lstStyle/>
+          <a:p>
+            <a:pPr indent="0" marL="0">
+              <a:buNone/>
+            </a:pPr>
+            <a:r>
+              <a:rPr lang="en-US" sz="1400" b="1" dirty="0">
+                <a:solidFill>
+                  <a:srgbClr val="9C7625"/>
                 </a:solidFill>
                 <a:latin typeface="Arial" pitchFamily="34" charset="0"/>
                 <a:ea typeface="Arial" pitchFamily="34" charset="-122"/>
                 <a:cs typeface="Arial" pitchFamily="34" charset="-120"/>
               </a:rPr>
-              <a:t>The problem and what discovery found</a:t>
-            </a:r>
-            <a:endParaRPr lang="en-US" sz="2600" dirty="0"/>
-          </a:p>
-        </p:txBody>
-      </p:sp>
-      <p:sp>
-        <p:nvSpPr>
-          <p:cNvPr id="3" name="Shape 1"/>
+              <a:t>Business problem</a:t>
+            </a:r>
+            <a:endParaRPr lang="en-US" sz="1400" dirty="0"/>
+          </a:p>
+        </p:txBody>
+      </p:sp>
+      <p:sp>
+        <p:nvSpPr>
+          <p:cNvPr id="5" name="Text 3"/>
+          <p:cNvSpPr txBox="1"/>
+          <p:nvPr/>
+        </p:nvSpPr>
+        <p:spPr>
+          <a:xfrm>
+            <a:off x="731520" y="2148840"/>
+            <a:ext cx="4572000" cy="3474720"/>
+          </a:xfrm>
+          <a:prstGeom prst="rect">
+            <a:avLst/>
+          </a:prstGeom>
+          <a:noFill/>
+          <a:ln/>
+        </p:spPr>
+        <p:txBody>
+          <a:bodyPr wrap="square" lIns="0" tIns="0" rIns="0" bIns="0" rtlCol="0" anchor="t"/>
+          <a:lstStyle/>
+          <a:p>
+            <a:pPr indent="0" marL="0">
+              <a:buNone/>
+            </a:pPr>
+            <a:r>
+              <a:rPr lang="en-US" sz="1700" dirty="0">
+                <a:solidFill>
+                  <a:srgbClr val="1E293B"/>
+                </a:solidFill>
+                <a:latin typeface="Arial" pitchFamily="34" charset="0"/>
+                <a:ea typeface="Arial" pitchFamily="34" charset="-122"/>
+                <a:cs typeface="Arial" pitchFamily="34" charset="-120"/>
+              </a:rPr>
+              <a:t>Fragmented delivery updates, repetitive customer enquiries and inconsistent custom-order requirement capture reduced visibility and created friction in the customer journey.</a:t>
+            </a:r>
+            <a:endParaRPr lang="en-US" sz="1700" dirty="0"/>
+          </a:p>
+        </p:txBody>
+      </p:sp>
+      <p:sp>
+        <p:nvSpPr>
+          <p:cNvPr id="6" name="Text 4"/>
+          <p:cNvSpPr txBox="1"/>
+          <p:nvPr/>
+        </p:nvSpPr>
+        <p:spPr>
+          <a:xfrm>
+            <a:off x="6126480" y="1691640"/>
+            <a:ext cx="5486400" cy="365760"/>
+          </a:xfrm>
+          <a:prstGeom prst="rect">
+            <a:avLst/>
+          </a:prstGeom>
+          <a:noFill/>
+          <a:ln/>
+        </p:spPr>
+        <p:txBody>
+          <a:bodyPr wrap="square" lIns="0" tIns="0" rIns="0" bIns="0" rtlCol="0" anchor="ctr"/>
+          <a:lstStyle/>
+          <a:p>
+            <a:pPr indent="0" marL="0">
+              <a:buNone/>
+            </a:pPr>
+            <a:r>
+              <a:rPr lang="en-US" sz="1400" b="1" dirty="0">
+                <a:solidFill>
+                  <a:srgbClr val="9C7625"/>
+                </a:solidFill>
+                <a:latin typeface="Arial" pitchFamily="34" charset="0"/>
+                <a:ea typeface="Arial" pitchFamily="34" charset="-122"/>
+                <a:cs typeface="Arial" pitchFamily="34" charset="-120"/>
+              </a:rPr>
+              <a:t>What the analysis found</a:t>
+            </a:r>
+            <a:endParaRPr lang="en-US" sz="1400" dirty="0"/>
+          </a:p>
+        </p:txBody>
+      </p:sp>
+      <p:sp>
+        <p:nvSpPr>
+          <p:cNvPr id="7" name="Shape 5"/>
           <p:cNvSpPr/>
           <p:nvPr/>
         </p:nvSpPr>
         <p:spPr>
           <a:xfrm>
-            <a:off x="457200" y="1463040"/>
-            <a:ext cx="5120640" cy="4480560"/>
-          </a:xfrm>
-          <a:prstGeom prst="rect">
+            <a:off x="6126480" y="2240280"/>
+            <a:ext cx="502920" cy="502920"/>
+          </a:xfrm>
+          <a:prstGeom prst="ellipse">
             <a:avLst/>
           </a:prstGeom>
           <a:solidFill>
-            <a:srgbClr val="F4F7FB"/>
+            <a:srgbClr val="C9A24A"/>
           </a:solidFill>
           <a:ln w="12700">
             <a:solidFill>
-              <a:srgbClr val="F4F7FB"/>
+              <a:srgbClr val="C9A24A"/>
             </a:solidFill>
             <a:prstDash val="solid"/>
           </a:ln>
         </p:spPr>
-      </p:sp>
-      <p:sp>
-        <p:nvSpPr>
-          <p:cNvPr id="4" name="Text 2"/>
+        <p:txBody>
+          <a:bodyPr/>
+          <a:p/>
+        </p:txBody>
+      </p:sp>
+      <p:sp>
+        <p:nvSpPr>
+          <p:cNvPr id="8" name="Text 6"/>
           <p:cNvSpPr txBox="1"/>
           <p:nvPr/>
         </p:nvSpPr>
         <p:spPr>
           <a:xfrm>
-            <a:off x="731520" y="1691640"/>
-            <a:ext cx="4572000" cy="365760"/>
+            <a:off x="6126480" y="2240280"/>
+            <a:ext cx="502920" cy="502920"/>
+          </a:xfrm>
+          <a:prstGeom prst="rect">
+            <a:avLst/>
+          </a:prstGeom>
+          <a:noFill/>
+          <a:ln/>
+        </p:spPr>
+        <p:txBody>
+          <a:bodyPr wrap="square" lIns="0" tIns="0" rIns="0" bIns="0" rtlCol="0" anchor="ctr"/>
+          <a:lstStyle/>
+          <a:p>
+            <a:pPr algn="ctr" indent="0" marL="0">
+              <a:buNone/>
+            </a:pPr>
+            <a:r>
+              <a:rPr lang="en-US" sz="1500" b="1" dirty="0">
+                <a:solidFill>
+                  <a:srgbClr val="FFFFFF"/>
+                </a:solidFill>
+                <a:latin typeface="Arial" pitchFamily="34" charset="0"/>
+                <a:ea typeface="Arial" pitchFamily="34" charset="-122"/>
+                <a:cs typeface="Arial" pitchFamily="34" charset="-120"/>
+              </a:rPr>
+              <a:t>1</a:t>
+            </a:r>
+            <a:endParaRPr lang="en-US" sz="1500" dirty="0"/>
+          </a:p>
+        </p:txBody>
+      </p:sp>
+      <p:sp>
+        <p:nvSpPr>
+          <p:cNvPr id="9" name="Text 7"/>
+          <p:cNvSpPr txBox="1"/>
+          <p:nvPr/>
+        </p:nvSpPr>
+        <p:spPr>
+          <a:xfrm>
+            <a:off x="6858000" y="2148840"/>
+            <a:ext cx="4846320" cy="731520"/>
           </a:xfrm>
           <a:prstGeom prst="rect">
             <a:avLst/>
@@ -1803,30 +2119,59 @@
               <a:buNone/>
             </a:pPr>
             <a:r>
-              <a:rPr lang="en-US" sz="1400" b="1" dirty="0">
-                <a:solidFill>
-                  <a:srgbClr val="0F766E"/>
+              <a:rPr lang="en-US" sz="1500" dirty="0">
+                <a:solidFill>
+                  <a:srgbClr val="1E293B"/>
                 </a:solidFill>
                 <a:latin typeface="Arial" pitchFamily="34" charset="0"/>
                 <a:ea typeface="Arial" pitchFamily="34" charset="-122"/>
                 <a:cs typeface="Arial" pitchFamily="34" charset="-120"/>
               </a:rPr>
-              <a:t>Business problem</a:t>
-            </a:r>
-            <a:endParaRPr lang="en-US" sz="1400" dirty="0"/>
-          </a:p>
-        </p:txBody>
-      </p:sp>
-      <p:sp>
-        <p:nvSpPr>
-          <p:cNvPr id="5" name="Text 3"/>
+              <a:t>Repeated WhatsApp questions consumed customer-service capacity</a:t>
+            </a:r>
+            <a:endParaRPr lang="en-US" sz="1500" dirty="0"/>
+          </a:p>
+        </p:txBody>
+      </p:sp>
+      <p:sp>
+        <p:nvSpPr>
+          <p:cNvPr id="10" name="Shape 8"/>
+          <p:cNvSpPr/>
+          <p:nvPr/>
+        </p:nvSpPr>
+        <p:spPr>
+          <a:xfrm>
+            <a:off x="6126480" y="3429000"/>
+            <a:ext cx="502920" cy="502920"/>
+          </a:xfrm>
+          <a:prstGeom prst="ellipse">
+            <a:avLst/>
+          </a:prstGeom>
+          <a:solidFill>
+            <a:srgbClr val="C9A24A"/>
+          </a:solidFill>
+          <a:ln w="12700">
+            <a:solidFill>
+              <a:srgbClr val="C9A24A"/>
+            </a:solidFill>
+            <a:prstDash val="solid"/>
+          </a:ln>
+        </p:spPr>
+        <p:txBody>
+          <a:bodyPr/>
+          <a:p/>
+        </p:txBody>
+      </p:sp>
+      <p:sp>
+        <p:nvSpPr>
+          <p:cNvPr id="11" name="Text 9"/>
           <p:cNvSpPr txBox="1"/>
           <p:nvPr/>
         </p:nvSpPr>
         <p:spPr>
           <a:xfrm>
-            <a:off x="731520" y="2148840"/>
-            <a:ext cx="4572000" cy="3474720"/>
+            <a:off x="6126480" y="3429000"/>
+            <a:ext cx="502920" cy="502920"/>
           </a:xfrm>
           <a:prstGeom prst="rect">
             <a:avLst/>
@@ -1835,14 +2180,53 @@
           <a:ln/>
         </p:spPr>
         <p:txBody>
-          <a:bodyPr wrap="square" lIns="0" tIns="0" rIns="0" bIns="0" rtlCol="0" anchor="t"/>
+          <a:bodyPr wrap="square" lIns="0" tIns="0" rIns="0" bIns="0" rtlCol="0" anchor="ctr"/>
+          <a:lstStyle/>
+          <a:p>
+            <a:pPr algn="ctr" indent="0" marL="0">
+              <a:buNone/>
+            </a:pPr>
+            <a:r>
+              <a:rPr lang="en-US" sz="1500" b="1" dirty="0">
+                <a:solidFill>
+                  <a:srgbClr val="FFFFFF"/>
+                </a:solidFill>
+                <a:latin typeface="Arial" pitchFamily="34" charset="0"/>
+                <a:ea typeface="Arial" pitchFamily="34" charset="-122"/>
+                <a:cs typeface="Arial" pitchFamily="34" charset="-120"/>
+              </a:rPr>
+              <a:t>2</a:t>
+            </a:r>
+            <a:endParaRPr lang="en-US" sz="1500" dirty="0"/>
+          </a:p>
+        </p:txBody>
+      </p:sp>
+      <p:sp>
+        <p:nvSpPr>
+          <p:cNvPr id="12" name="Text 10"/>
+          <p:cNvSpPr txBox="1"/>
+          <p:nvPr/>
+        </p:nvSpPr>
+        <p:spPr>
+          <a:xfrm>
+            <a:off x="6858000" y="3337560"/>
+            <a:ext cx="4846320" cy="731520"/>
+          </a:xfrm>
+          <a:prstGeom prst="rect">
+            <a:avLst/>
+          </a:prstGeom>
+          <a:noFill/>
+          <a:ln/>
+        </p:spPr>
+        <p:txBody>
+          <a:bodyPr wrap="square" lIns="0" tIns="0" rIns="0" bIns="0" rtlCol="0" anchor="ctr"/>
           <a:lstStyle/>
           <a:p>
             <a:pPr indent="0" marL="0">
               <a:buNone/>
             </a:pPr>
             <a:r>
-              <a:rPr lang="en-US" sz="1700" dirty="0">
+              <a:rPr lang="en-US" sz="1500" dirty="0">
                 <a:solidFill>
                   <a:srgbClr val="1E293B"/>
                 </a:solidFill>
@@ -1850,22 +2234,90 @@
                 <a:ea typeface="Arial" pitchFamily="34" charset="-122"/>
                 <a:cs typeface="Arial" pitchFamily="34" charset="-120"/>
               </a:rPr>
-              <a:t>Fragmented delivery updates, repetitive customer enquiries and inconsistent custom-order requirement capture reduced visibility and created friction in the customer journey.</a:t>
-            </a:r>
-            <a:endParaRPr lang="en-US" sz="1700" dirty="0"/>
-          </a:p>
-        </p:txBody>
-      </p:sp>
-      <p:sp>
-        <p:nvSpPr>
-          <p:cNvPr id="6" name="Text 4"/>
+              <a:t>Custom-order details were captured inconsistently, causing disputes and rework</a:t>
+            </a:r>
+            <a:endParaRPr lang="en-US" sz="1500" dirty="0"/>
+          </a:p>
+        </p:txBody>
+      </p:sp>
+      <p:sp>
+        <p:nvSpPr>
+          <p:cNvPr id="13" name="Shape 11"/>
+          <p:cNvSpPr/>
+          <p:nvPr/>
+        </p:nvSpPr>
+        <p:spPr>
+          <a:xfrm>
+            <a:off x="6126480" y="4617720"/>
+            <a:ext cx="502920" cy="502920"/>
+          </a:xfrm>
+          <a:prstGeom prst="ellipse">
+            <a:avLst/>
+          </a:prstGeom>
+          <a:solidFill>
+            <a:srgbClr val="C9A24A"/>
+          </a:solidFill>
+          <a:ln w="12700">
+            <a:solidFill>
+              <a:srgbClr val="C9A24A"/>
+            </a:solidFill>
+            <a:prstDash val="solid"/>
+          </a:ln>
+        </p:spPr>
+        <p:txBody>
+          <a:bodyPr/>
+          <a:p/>
+        </p:txBody>
+      </p:sp>
+      <p:sp>
+        <p:nvSpPr>
+          <p:cNvPr id="14" name="Text 12"/>
           <p:cNvSpPr txBox="1"/>
           <p:nvPr/>
         </p:nvSpPr>
         <p:spPr>
           <a:xfrm>
-            <a:off x="6126480" y="1691640"/>
-            <a:ext cx="5486400" cy="365760"/>
+            <a:off x="6126480" y="4617720"/>
+            <a:ext cx="502920" cy="502920"/>
+          </a:xfrm>
+          <a:prstGeom prst="rect">
+            <a:avLst/>
+          </a:prstGeom>
+          <a:noFill/>
+          <a:ln/>
+        </p:spPr>
+        <p:txBody>
+          <a:bodyPr wrap="square" lIns="0" tIns="0" rIns="0" bIns="0" rtlCol="0" anchor="ctr"/>
+          <a:lstStyle/>
+          <a:p>
+            <a:pPr algn="ctr" indent="0" marL="0">
+              <a:buNone/>
+            </a:pPr>
+            <a:r>
+              <a:rPr lang="en-US" sz="1500" b="1" dirty="0">
+                <a:solidFill>
+                  <a:srgbClr val="FFFFFF"/>
+                </a:solidFill>
+                <a:latin typeface="Arial" pitchFamily="34" charset="0"/>
+                <a:ea typeface="Arial" pitchFamily="34" charset="-122"/>
+                <a:cs typeface="Arial" pitchFamily="34" charset="-120"/>
+              </a:rPr>
+              <a:t>3</a:t>
+            </a:r>
+            <a:endParaRPr lang="en-US" sz="1500" dirty="0"/>
+          </a:p>
+        </p:txBody>
+      </p:sp>
+      <p:sp>
+        <p:nvSpPr>
+          <p:cNvPr id="15" name="Text 13"/>
+          <p:cNvSpPr txBox="1"/>
+          <p:nvPr/>
+        </p:nvSpPr>
+        <p:spPr>
+          <a:xfrm>
+            <a:off x="6858000" y="4526280"/>
+            <a:ext cx="4846320" cy="731520"/>
           </a:xfrm>
           <a:prstGeom prst="rect">
             <a:avLst/>
@@ -1881,55 +2333,30 @@
               <a:buNone/>
             </a:pPr>
             <a:r>
-              <a:rPr lang="en-US" sz="1400" b="1" dirty="0">
-                <a:solidFill>
-                  <a:srgbClr val="0F766E"/>
+              <a:rPr lang="en-US" sz="1500" dirty="0">
+                <a:solidFill>
+                  <a:srgbClr val="1E293B"/>
                 </a:solidFill>
                 <a:latin typeface="Arial" pitchFamily="34" charset="0"/>
                 <a:ea typeface="Arial" pitchFamily="34" charset="-122"/>
                 <a:cs typeface="Arial" pitchFamily="34" charset="-120"/>
               </a:rPr>
-              <a:t>What the analysis found</a:t>
-            </a:r>
-            <a:endParaRPr lang="en-US" sz="1400" dirty="0"/>
-          </a:p>
-        </p:txBody>
-      </p:sp>
-      <p:sp>
-        <p:nvSpPr>
-          <p:cNvPr id="7" name="Shape 5"/>
-          <p:cNvSpPr/>
-          <p:nvPr/>
-        </p:nvSpPr>
-        <p:spPr>
-          <a:xfrm>
-            <a:off x="6126480" y="2240280"/>
-            <a:ext cx="502920" cy="502920"/>
-          </a:xfrm>
-          <a:prstGeom prst="ellipse">
-            <a:avLst/>
-          </a:prstGeom>
-          <a:solidFill>
-            <a:srgbClr val="EA580C"/>
-          </a:solidFill>
-          <a:ln w="12700">
-            <a:solidFill>
-              <a:srgbClr val="EA580C"/>
-            </a:solidFill>
-            <a:prstDash val="solid"/>
-          </a:ln>
-        </p:spPr>
-      </p:sp>
-      <p:sp>
-        <p:nvSpPr>
-          <p:cNvPr id="8" name="Text 6"/>
+              <a:t>Project updates sat across separate channels and documents</a:t>
+            </a:r>
+            <a:endParaRPr lang="en-US" sz="1500" dirty="0"/>
+          </a:p>
+        </p:txBody>
+      </p:sp>
+      <p:sp>
+        <p:nvSpPr>
+          <p:cNvPr id="16" name="Text 14"/>
           <p:cNvSpPr txBox="1"/>
           <p:nvPr/>
         </p:nvSpPr>
         <p:spPr>
           <a:xfrm>
-            <a:off x="6126480" y="2240280"/>
-            <a:ext cx="502920" cy="502920"/>
+            <a:off x="457200" y="6446520"/>
+            <a:ext cx="8229600" cy="274320"/>
           </a:xfrm>
           <a:prstGeom prst="rect">
             <a:avLst/>
@@ -1941,34 +2368,34 @@
           <a:bodyPr wrap="square" lIns="0" tIns="0" rIns="0" bIns="0" rtlCol="0" anchor="ctr"/>
           <a:lstStyle/>
           <a:p>
-            <a:pPr algn="ctr" indent="0" marL="0">
+            <a:pPr indent="0" marL="0">
               <a:buNone/>
             </a:pPr>
             <a:r>
-              <a:rPr lang="en-US" sz="1500" b="1" dirty="0">
-                <a:solidFill>
-                  <a:srgbClr val="FFFFFF"/>
+              <a:rPr lang="en-US" sz="900" dirty="0">
+                <a:solidFill>
+                  <a:srgbClr val="64748B"/>
                 </a:solidFill>
                 <a:latin typeface="Arial" pitchFamily="34" charset="0"/>
                 <a:ea typeface="Arial" pitchFamily="34" charset="-122"/>
                 <a:cs typeface="Arial" pitchFamily="34" charset="-120"/>
               </a:rPr>
-              <a:t>1</a:t>
-            </a:r>
-            <a:endParaRPr lang="en-US" sz="1500" dirty="0"/>
-          </a:p>
-        </p:txBody>
-      </p:sp>
-      <p:sp>
-        <p:nvSpPr>
-          <p:cNvPr id="9" name="Text 7"/>
+              <a:t>BOZ Jewelry  |  Olalekan Ajimoti, Business Analyst portfolio</a:t>
+            </a:r>
+            <a:endParaRPr lang="en-US" sz="900" dirty="0"/>
+          </a:p>
+        </p:txBody>
+      </p:sp>
+      <p:sp>
+        <p:nvSpPr>
+          <p:cNvPr id="17" name="Text 15"/>
           <p:cNvSpPr txBox="1"/>
           <p:nvPr/>
         </p:nvSpPr>
         <p:spPr>
           <a:xfrm>
-            <a:off x="6858000" y="2148840"/>
-            <a:ext cx="4846320" cy="731520"/>
+            <a:off x="11247120" y="6446520"/>
+            <a:ext cx="548640" cy="274320"/>
           </a:xfrm>
           <a:prstGeom prst="rect">
             <a:avLst/>
@@ -1980,305 +2407,144 @@
           <a:bodyPr wrap="square" lIns="0" tIns="0" rIns="0" bIns="0" rtlCol="0" anchor="ctr"/>
           <a:lstStyle/>
           <a:p>
-            <a:pPr indent="0" marL="0">
+            <a:pPr algn="r" indent="0" marL="0">
               <a:buNone/>
             </a:pPr>
             <a:r>
-              <a:rPr lang="en-US" sz="1500" dirty="0">
-                <a:solidFill>
-                  <a:srgbClr val="1E293B"/>
+              <a:rPr lang="en-US" sz="900" dirty="0">
+                <a:solidFill>
+                  <a:srgbClr val="64748B"/>
                 </a:solidFill>
                 <a:latin typeface="Arial" pitchFamily="34" charset="0"/>
                 <a:ea typeface="Arial" pitchFamily="34" charset="-122"/>
                 <a:cs typeface="Arial" pitchFamily="34" charset="-120"/>
               </a:rPr>
-              <a:t>Repeated WhatsApp questions consumed customer-service capacity</a:t>
-            </a:r>
-            <a:endParaRPr lang="en-US" sz="1500" dirty="0"/>
-          </a:p>
-        </p:txBody>
-      </p:sp>
-      <p:sp>
-        <p:nvSpPr>
-          <p:cNvPr id="10" name="Shape 8"/>
+              <a:t>02</a:t>
+            </a:r>
+            <a:endParaRPr lang="en-US" sz="900" dirty="0"/>
+          </a:p>
+        </p:txBody>
+      </p:sp>
+      <p:sp>
+        <p:nvSpPr>
+          <p:cNvPr id="18" name="Rectangle 17"/>
           <p:cNvSpPr/>
           <p:nvPr/>
         </p:nvSpPr>
         <p:spPr>
           <a:xfrm>
-            <a:off x="6126480" y="3429000"/>
-            <a:ext cx="502920" cy="502920"/>
-          </a:xfrm>
-          <a:prstGeom prst="ellipse">
+            <a:off x="0" y="0"/>
+            <a:ext cx="12192000" cy="82296"/>
+          </a:xfrm>
+          <a:prstGeom prst="rect">
             <a:avLst/>
           </a:prstGeom>
           <a:solidFill>
-            <a:srgbClr val="EA580C"/>
+            <a:srgbClr val="3A2A12"/>
           </a:solidFill>
-          <a:ln w="12700">
-            <a:solidFill>
-              <a:srgbClr val="EA580C"/>
-            </a:solidFill>
-            <a:prstDash val="solid"/>
+          <a:ln>
+            <a:noFill/>
           </a:ln>
-        </p:spPr>
-      </p:sp>
-      <p:sp>
-        <p:nvSpPr>
-          <p:cNvPr id="11" name="Text 9"/>
+          <a:effectLst/>
+        </p:spPr>
+        <p:style>
+          <a:lnRef idx="1">
+            <a:schemeClr val="accent1"/>
+          </a:lnRef>
+          <a:fillRef idx="3">
+            <a:schemeClr val="accent1"/>
+          </a:fillRef>
+          <a:effectRef idx="2">
+            <a:schemeClr val="accent1"/>
+          </a:effectRef>
+          <a:fontRef idx="minor">
+            <a:schemeClr val="lt1"/>
+          </a:fontRef>
+        </p:style>
+        <p:txBody>
+          <a:bodyPr rtlCol="0" anchor="ctr"/>
+          <a:lstStyle/>
+          <a:p>
+            <a:pPr algn="ctr"/>
+          </a:p>
+        </p:txBody>
+      </p:sp>
+      <p:sp>
+        <p:nvSpPr>
+          <p:cNvPr id="19" name="Rectangle 18"/>
+          <p:cNvSpPr/>
+          <p:nvPr/>
+        </p:nvSpPr>
+        <p:spPr>
+          <a:xfrm>
+            <a:off x="0" y="82296"/>
+            <a:ext cx="1463040" cy="45720"/>
+          </a:xfrm>
+          <a:prstGeom prst="rect">
+            <a:avLst/>
+          </a:prstGeom>
+          <a:solidFill>
+            <a:srgbClr val="C9A24A"/>
+          </a:solidFill>
+          <a:ln>
+            <a:noFill/>
+          </a:ln>
+          <a:effectLst/>
+        </p:spPr>
+        <p:style>
+          <a:lnRef idx="1">
+            <a:schemeClr val="accent1"/>
+          </a:lnRef>
+          <a:fillRef idx="3">
+            <a:schemeClr val="accent1"/>
+          </a:fillRef>
+          <a:effectRef idx="2">
+            <a:schemeClr val="accent1"/>
+          </a:effectRef>
+          <a:fontRef idx="minor">
+            <a:schemeClr val="lt1"/>
+          </a:fontRef>
+        </p:style>
+        <p:txBody>
+          <a:bodyPr rtlCol="0" anchor="ctr"/>
+          <a:lstStyle/>
+          <a:p>
+            <a:pPr algn="ctr"/>
+          </a:p>
+        </p:txBody>
+      </p:sp>
+      <p:sp>
+        <p:nvSpPr>
+          <p:cNvPr id="20" name="TextBox 19"/>
           <p:cNvSpPr txBox="1"/>
           <p:nvPr/>
         </p:nvSpPr>
         <p:spPr>
           <a:xfrm>
-            <a:off x="6126480" y="3429000"/>
-            <a:ext cx="502920" cy="502920"/>
+            <a:off x="10088880" y="6327648"/>
+            <a:ext cx="1463040" cy="384048"/>
           </a:xfrm>
           <a:prstGeom prst="rect">
             <a:avLst/>
           </a:prstGeom>
           <a:noFill/>
-          <a:ln/>
-        </p:spPr>
-        <p:txBody>
-          <a:bodyPr wrap="square" lIns="0" tIns="0" rIns="0" bIns="0" rtlCol="0" anchor="ctr"/>
-          <a:lstStyle/>
-          <a:p>
-            <a:pPr algn="ctr" indent="0" marL="0">
-              <a:buNone/>
-            </a:pPr>
-            <a:r>
-              <a:rPr lang="en-US" sz="1500" b="1" dirty="0">
-                <a:solidFill>
-                  <a:srgbClr val="FFFFFF"/>
-                </a:solidFill>
-                <a:latin typeface="Arial" pitchFamily="34" charset="0"/>
-                <a:ea typeface="Arial" pitchFamily="34" charset="-122"/>
-                <a:cs typeface="Arial" pitchFamily="34" charset="-120"/>
-              </a:rPr>
-              <a:t>2</a:t>
-            </a:r>
-            <a:endParaRPr lang="en-US" sz="1500" dirty="0"/>
-          </a:p>
-        </p:txBody>
-      </p:sp>
-      <p:sp>
-        <p:nvSpPr>
-          <p:cNvPr id="12" name="Text 10"/>
-          <p:cNvSpPr txBox="1"/>
-          <p:nvPr/>
-        </p:nvSpPr>
-        <p:spPr>
-          <a:xfrm>
-            <a:off x="6858000" y="3337560"/>
-            <a:ext cx="4846320" cy="731520"/>
-          </a:xfrm>
-          <a:prstGeom prst="rect">
-            <a:avLst/>
-          </a:prstGeom>
-          <a:noFill/>
-          <a:ln/>
-        </p:spPr>
-        <p:txBody>
-          <a:bodyPr wrap="square" lIns="0" tIns="0" rIns="0" bIns="0" rtlCol="0" anchor="ctr"/>
-          <a:lstStyle/>
-          <a:p>
-            <a:pPr indent="0" marL="0">
-              <a:buNone/>
-            </a:pPr>
-            <a:r>
-              <a:rPr lang="en-US" sz="1500" dirty="0">
-                <a:solidFill>
-                  <a:srgbClr val="1E293B"/>
-                </a:solidFill>
-                <a:latin typeface="Arial" pitchFamily="34" charset="0"/>
-                <a:ea typeface="Arial" pitchFamily="34" charset="-122"/>
-                <a:cs typeface="Arial" pitchFamily="34" charset="-120"/>
-              </a:rPr>
-              <a:t>Custom-order details were captured inconsistently, causing disputes and rework</a:t>
-            </a:r>
-            <a:endParaRPr lang="en-US" sz="1500" dirty="0"/>
-          </a:p>
-        </p:txBody>
-      </p:sp>
-      <p:sp>
-        <p:nvSpPr>
-          <p:cNvPr id="13" name="Shape 11"/>
-          <p:cNvSpPr/>
-          <p:nvPr/>
-        </p:nvSpPr>
-        <p:spPr>
-          <a:xfrm>
-            <a:off x="6126480" y="4617720"/>
-            <a:ext cx="502920" cy="502920"/>
-          </a:xfrm>
-          <a:prstGeom prst="ellipse">
-            <a:avLst/>
-          </a:prstGeom>
-          <a:solidFill>
-            <a:srgbClr val="EA580C"/>
-          </a:solidFill>
-          <a:ln w="12700">
-            <a:solidFill>
-              <a:srgbClr val="EA580C"/>
-            </a:solidFill>
-            <a:prstDash val="solid"/>
-          </a:ln>
-        </p:spPr>
-      </p:sp>
-      <p:sp>
-        <p:nvSpPr>
-          <p:cNvPr id="14" name="Text 12"/>
-          <p:cNvSpPr txBox="1"/>
-          <p:nvPr/>
-        </p:nvSpPr>
-        <p:spPr>
-          <a:xfrm>
-            <a:off x="6126480" y="4617720"/>
-            <a:ext cx="502920" cy="502920"/>
-          </a:xfrm>
-          <a:prstGeom prst="rect">
-            <a:avLst/>
-          </a:prstGeom>
-          <a:noFill/>
-          <a:ln/>
-        </p:spPr>
-        <p:txBody>
-          <a:bodyPr wrap="square" lIns="0" tIns="0" rIns="0" bIns="0" rtlCol="0" anchor="ctr"/>
-          <a:lstStyle/>
-          <a:p>
-            <a:pPr algn="ctr" indent="0" marL="0">
-              <a:buNone/>
-            </a:pPr>
-            <a:r>
-              <a:rPr lang="en-US" sz="1500" b="1" dirty="0">
-                <a:solidFill>
-                  <a:srgbClr val="FFFFFF"/>
-                </a:solidFill>
-                <a:latin typeface="Arial" pitchFamily="34" charset="0"/>
-                <a:ea typeface="Arial" pitchFamily="34" charset="-122"/>
-                <a:cs typeface="Arial" pitchFamily="34" charset="-120"/>
-              </a:rPr>
-              <a:t>3</a:t>
-            </a:r>
-            <a:endParaRPr lang="en-US" sz="1500" dirty="0"/>
-          </a:p>
-        </p:txBody>
-      </p:sp>
-      <p:sp>
-        <p:nvSpPr>
-          <p:cNvPr id="15" name="Text 13"/>
-          <p:cNvSpPr txBox="1"/>
-          <p:nvPr/>
-        </p:nvSpPr>
-        <p:spPr>
-          <a:xfrm>
-            <a:off x="6858000" y="4526280"/>
-            <a:ext cx="4846320" cy="731520"/>
-          </a:xfrm>
-          <a:prstGeom prst="rect">
-            <a:avLst/>
-          </a:prstGeom>
-          <a:noFill/>
-          <a:ln/>
-        </p:spPr>
-        <p:txBody>
-          <a:bodyPr wrap="square" lIns="0" tIns="0" rIns="0" bIns="0" rtlCol="0" anchor="ctr"/>
-          <a:lstStyle/>
-          <a:p>
-            <a:pPr indent="0" marL="0">
-              <a:buNone/>
-            </a:pPr>
-            <a:r>
-              <a:rPr lang="en-US" sz="1500" dirty="0">
-                <a:solidFill>
-                  <a:srgbClr val="1E293B"/>
-                </a:solidFill>
-                <a:latin typeface="Arial" pitchFamily="34" charset="0"/>
-                <a:ea typeface="Arial" pitchFamily="34" charset="-122"/>
-                <a:cs typeface="Arial" pitchFamily="34" charset="-120"/>
-              </a:rPr>
-              <a:t>Project updates sat across separate channels and documents</a:t>
-            </a:r>
-            <a:endParaRPr lang="en-US" sz="1500" dirty="0"/>
-          </a:p>
-        </p:txBody>
-      </p:sp>
-      <p:sp>
-        <p:nvSpPr>
-          <p:cNvPr id="16" name="Text 14"/>
-          <p:cNvSpPr txBox="1"/>
-          <p:nvPr/>
-        </p:nvSpPr>
-        <p:spPr>
-          <a:xfrm>
-            <a:off x="457200" y="6446520"/>
-            <a:ext cx="8229600" cy="274320"/>
-          </a:xfrm>
-          <a:prstGeom prst="rect">
-            <a:avLst/>
-          </a:prstGeom>
-          <a:noFill/>
-          <a:ln/>
-        </p:spPr>
-        <p:txBody>
-          <a:bodyPr wrap="square" lIns="0" tIns="0" rIns="0" bIns="0" rtlCol="0" anchor="ctr"/>
-          <a:lstStyle/>
-          <a:p>
-            <a:pPr indent="0" marL="0">
-              <a:buNone/>
-            </a:pPr>
-            <a:r>
-              <a:rPr lang="en-US" sz="900" dirty="0">
-                <a:solidFill>
-                  <a:srgbClr val="64748B"/>
-                </a:solidFill>
-                <a:latin typeface="Arial" pitchFamily="34" charset="0"/>
-                <a:ea typeface="Arial" pitchFamily="34" charset="-122"/>
-                <a:cs typeface="Arial" pitchFamily="34" charset="-120"/>
-              </a:rPr>
-              <a:t>BOZ Jewelry  |  Olalekan Ajimoti, Business Analyst portfolio</a:t>
-            </a:r>
-            <a:endParaRPr lang="en-US" sz="900" dirty="0"/>
-          </a:p>
-        </p:txBody>
-      </p:sp>
-      <p:sp>
-        <p:nvSpPr>
-          <p:cNvPr id="17" name="Text 15"/>
-          <p:cNvSpPr txBox="1"/>
-          <p:nvPr/>
-        </p:nvSpPr>
-        <p:spPr>
-          <a:xfrm>
-            <a:off x="11247120" y="6446520"/>
-            <a:ext cx="548640" cy="274320"/>
-          </a:xfrm>
-          <a:prstGeom prst="rect">
-            <a:avLst/>
-          </a:prstGeom>
-          <a:noFill/>
-          <a:ln/>
-        </p:spPr>
-        <p:txBody>
-          <a:bodyPr wrap="square" lIns="0" tIns="0" rIns="0" bIns="0" rtlCol="0" anchor="ctr"/>
-          <a:lstStyle/>
-          <a:p>
-            <a:pPr algn="r" indent="0" marL="0">
-              <a:buNone/>
-            </a:pPr>
-            <a:r>
-              <a:rPr lang="en-US" sz="900" dirty="0">
-                <a:solidFill>
-                  <a:srgbClr val="64748B"/>
-                </a:solidFill>
-                <a:latin typeface="Arial" pitchFamily="34" charset="0"/>
-                <a:ea typeface="Arial" pitchFamily="34" charset="-122"/>
-                <a:cs typeface="Arial" pitchFamily="34" charset="-120"/>
-              </a:rPr>
-              <a:t>02</a:t>
-            </a:r>
-            <a:endParaRPr lang="en-US" sz="900" dirty="0"/>
+        </p:spPr>
+        <p:txBody>
+          <a:bodyPr wrap="none" anchor="ctr">
+            <a:spAutoFit/>
+          </a:bodyPr>
+          <a:lstStyle/>
+          <a:p>
+            <a:pPr algn="ctr"/>
+            <a:r>
+              <a:rPr sz="1300" b="1">
+                <a:solidFill>
+                  <a:srgbClr val="3A2A12"/>
+                </a:solidFill>
+                <a:latin typeface="Liberation Serif"/>
+              </a:rPr>
+              <a:t>BOZ</a:t>
+            </a:r>
           </a:p>
         </p:txBody>
       </p:sp>
@@ -2341,11 +2607,11 @@
             <a:r>
               <a:rPr lang="en-US" sz="2600" b="1" dirty="0">
                 <a:solidFill>
-                  <a:srgbClr val="15253D"/>
-                </a:solidFill>
-                <a:latin typeface="Arial" pitchFamily="34" charset="0"/>
-                <a:ea typeface="Arial" pitchFamily="34" charset="-122"/>
-                <a:cs typeface="Arial" pitchFamily="34" charset="-120"/>
+                  <a:srgbClr val="3A2A12"/>
+                </a:solidFill>
+                <a:latin typeface="Liberation Serif" pitchFamily="34" charset="0"/>
+                <a:ea typeface="Liberation Serif" pitchFamily="34" charset="-122"/>
+                <a:cs typeface="Liberation Serif" pitchFamily="34" charset="-120"/>
               </a:rPr>
               <a:t>As-Is process</a:t>
             </a:r>
@@ -2491,6 +2757,129 @@
               <a:t>03</a:t>
             </a:r>
             <a:endParaRPr lang="en-US" sz="900" dirty="0"/>
+          </a:p>
+        </p:txBody>
+      </p:sp>
+      <p:sp>
+        <p:nvSpPr>
+          <p:cNvPr id="7" name="Rectangle 6"/>
+          <p:cNvSpPr/>
+          <p:nvPr/>
+        </p:nvSpPr>
+        <p:spPr>
+          <a:xfrm>
+            <a:off x="0" y="0"/>
+            <a:ext cx="12192000" cy="82296"/>
+          </a:xfrm>
+          <a:prstGeom prst="rect">
+            <a:avLst/>
+          </a:prstGeom>
+          <a:solidFill>
+            <a:srgbClr val="3A2A12"/>
+          </a:solidFill>
+          <a:ln>
+            <a:noFill/>
+          </a:ln>
+          <a:effectLst/>
+        </p:spPr>
+        <p:style>
+          <a:lnRef idx="1">
+            <a:schemeClr val="accent1"/>
+          </a:lnRef>
+          <a:fillRef idx="3">
+            <a:schemeClr val="accent1"/>
+          </a:fillRef>
+          <a:effectRef idx="2">
+            <a:schemeClr val="accent1"/>
+          </a:effectRef>
+          <a:fontRef idx="minor">
+            <a:schemeClr val="lt1"/>
+          </a:fontRef>
+        </p:style>
+        <p:txBody>
+          <a:bodyPr rtlCol="0" anchor="ctr"/>
+          <a:lstStyle/>
+          <a:p>
+            <a:pPr algn="ctr"/>
+          </a:p>
+        </p:txBody>
+      </p:sp>
+      <p:sp>
+        <p:nvSpPr>
+          <p:cNvPr id="8" name="Rectangle 7"/>
+          <p:cNvSpPr/>
+          <p:nvPr/>
+        </p:nvSpPr>
+        <p:spPr>
+          <a:xfrm>
+            <a:off x="0" y="82296"/>
+            <a:ext cx="1463040" cy="45720"/>
+          </a:xfrm>
+          <a:prstGeom prst="rect">
+            <a:avLst/>
+          </a:prstGeom>
+          <a:solidFill>
+            <a:srgbClr val="C9A24A"/>
+          </a:solidFill>
+          <a:ln>
+            <a:noFill/>
+          </a:ln>
+          <a:effectLst/>
+        </p:spPr>
+        <p:style>
+          <a:lnRef idx="1">
+            <a:schemeClr val="accent1"/>
+          </a:lnRef>
+          <a:fillRef idx="3">
+            <a:schemeClr val="accent1"/>
+          </a:fillRef>
+          <a:effectRef idx="2">
+            <a:schemeClr val="accent1"/>
+          </a:effectRef>
+          <a:fontRef idx="minor">
+            <a:schemeClr val="lt1"/>
+          </a:fontRef>
+        </p:style>
+        <p:txBody>
+          <a:bodyPr rtlCol="0" anchor="ctr"/>
+          <a:lstStyle/>
+          <a:p>
+            <a:pPr algn="ctr"/>
+          </a:p>
+        </p:txBody>
+      </p:sp>
+      <p:sp>
+        <p:nvSpPr>
+          <p:cNvPr id="9" name="TextBox 8"/>
+          <p:cNvSpPr txBox="1"/>
+          <p:nvPr/>
+        </p:nvSpPr>
+        <p:spPr>
+          <a:xfrm>
+            <a:off x="10088880" y="6327648"/>
+            <a:ext cx="1463040" cy="384048"/>
+          </a:xfrm>
+          <a:prstGeom prst="rect">
+            <a:avLst/>
+          </a:prstGeom>
+          <a:noFill/>
+        </p:spPr>
+        <p:txBody>
+          <a:bodyPr wrap="none" anchor="ctr">
+            <a:spAutoFit/>
+          </a:bodyPr>
+          <a:lstStyle/>
+          <a:p>
+            <a:pPr algn="ctr"/>
+            <a:r>
+              <a:rPr sz="1300" b="1">
+                <a:solidFill>
+                  <a:srgbClr val="3A2A12"/>
+                </a:solidFill>
+                <a:latin typeface="Liberation Serif"/>
+              </a:rPr>
+              <a:t>BOZ</a:t>
+            </a:r>
           </a:p>
         </p:txBody>
       </p:sp>
@@ -2553,11 +2942,11 @@
             <a:r>
               <a:rPr lang="en-US" sz="2600" b="1" dirty="0">
                 <a:solidFill>
-                  <a:srgbClr val="15253D"/>
-                </a:solidFill>
-                <a:latin typeface="Arial" pitchFamily="34" charset="0"/>
-                <a:ea typeface="Arial" pitchFamily="34" charset="-122"/>
-                <a:cs typeface="Arial" pitchFamily="34" charset="-120"/>
+                  <a:srgbClr val="3A2A12"/>
+                </a:solidFill>
+                <a:latin typeface="Liberation Serif" pitchFamily="34" charset="0"/>
+                <a:ea typeface="Liberation Serif" pitchFamily="34" charset="-122"/>
+                <a:cs typeface="Liberation Serif" pitchFamily="34" charset="-120"/>
               </a:rPr>
               <a:t>To-Be process</a:t>
             </a:r>
@@ -2703,6 +3092,129 @@
               <a:t>04</a:t>
             </a:r>
             <a:endParaRPr lang="en-US" sz="900" dirty="0"/>
+          </a:p>
+        </p:txBody>
+      </p:sp>
+      <p:sp>
+        <p:nvSpPr>
+          <p:cNvPr id="7" name="Rectangle 6"/>
+          <p:cNvSpPr/>
+          <p:nvPr/>
+        </p:nvSpPr>
+        <p:spPr>
+          <a:xfrm>
+            <a:off x="0" y="0"/>
+            <a:ext cx="12192000" cy="82296"/>
+          </a:xfrm>
+          <a:prstGeom prst="rect">
+            <a:avLst/>
+          </a:prstGeom>
+          <a:solidFill>
+            <a:srgbClr val="3A2A12"/>
+          </a:solidFill>
+          <a:ln>
+            <a:noFill/>
+          </a:ln>
+          <a:effectLst/>
+        </p:spPr>
+        <p:style>
+          <a:lnRef idx="1">
+            <a:schemeClr val="accent1"/>
+          </a:lnRef>
+          <a:fillRef idx="3">
+            <a:schemeClr val="accent1"/>
+          </a:fillRef>
+          <a:effectRef idx="2">
+            <a:schemeClr val="accent1"/>
+          </a:effectRef>
+          <a:fontRef idx="minor">
+            <a:schemeClr val="lt1"/>
+          </a:fontRef>
+        </p:style>
+        <p:txBody>
+          <a:bodyPr rtlCol="0" anchor="ctr"/>
+          <a:lstStyle/>
+          <a:p>
+            <a:pPr algn="ctr"/>
+          </a:p>
+        </p:txBody>
+      </p:sp>
+      <p:sp>
+        <p:nvSpPr>
+          <p:cNvPr id="8" name="Rectangle 7"/>
+          <p:cNvSpPr/>
+          <p:nvPr/>
+        </p:nvSpPr>
+        <p:spPr>
+          <a:xfrm>
+            <a:off x="0" y="82296"/>
+            <a:ext cx="1463040" cy="45720"/>
+          </a:xfrm>
+          <a:prstGeom prst="rect">
+            <a:avLst/>
+          </a:prstGeom>
+          <a:solidFill>
+            <a:srgbClr val="C9A24A"/>
+          </a:solidFill>
+          <a:ln>
+            <a:noFill/>
+          </a:ln>
+          <a:effectLst/>
+        </p:spPr>
+        <p:style>
+          <a:lnRef idx="1">
+            <a:schemeClr val="accent1"/>
+          </a:lnRef>
+          <a:fillRef idx="3">
+            <a:schemeClr val="accent1"/>
+          </a:fillRef>
+          <a:effectRef idx="2">
+            <a:schemeClr val="accent1"/>
+          </a:effectRef>
+          <a:fontRef idx="minor">
+            <a:schemeClr val="lt1"/>
+          </a:fontRef>
+        </p:style>
+        <p:txBody>
+          <a:bodyPr rtlCol="0" anchor="ctr"/>
+          <a:lstStyle/>
+          <a:p>
+            <a:pPr algn="ctr"/>
+          </a:p>
+        </p:txBody>
+      </p:sp>
+      <p:sp>
+        <p:nvSpPr>
+          <p:cNvPr id="9" name="TextBox 8"/>
+          <p:cNvSpPr txBox="1"/>
+          <p:nvPr/>
+        </p:nvSpPr>
+        <p:spPr>
+          <a:xfrm>
+            <a:off x="10088880" y="6327648"/>
+            <a:ext cx="1463040" cy="384048"/>
+          </a:xfrm>
+          <a:prstGeom prst="rect">
+            <a:avLst/>
+          </a:prstGeom>
+          <a:noFill/>
+        </p:spPr>
+        <p:txBody>
+          <a:bodyPr wrap="none" anchor="ctr">
+            <a:spAutoFit/>
+          </a:bodyPr>
+          <a:lstStyle/>
+          <a:p>
+            <a:pPr algn="ctr"/>
+            <a:r>
+              <a:rPr sz="1300" b="1">
+                <a:solidFill>
+                  <a:srgbClr val="3A2A12"/>
+                </a:solidFill>
+                <a:latin typeface="Liberation Serif"/>
+              </a:rPr>
+              <a:t>BOZ</a:t>
+            </a:r>
           </a:p>
         </p:txBody>
       </p:sp>
@@ -2765,11 +3277,11 @@
             <a:r>
               <a:rPr lang="en-US" sz="2600" b="1" dirty="0">
                 <a:solidFill>
-                  <a:srgbClr val="15253D"/>
-                </a:solidFill>
-                <a:latin typeface="Arial" pitchFamily="34" charset="0"/>
-                <a:ea typeface="Arial" pitchFamily="34" charset="-122"/>
-                <a:cs typeface="Arial" pitchFamily="34" charset="-120"/>
+                  <a:srgbClr val="3A2A12"/>
+                </a:solidFill>
+                <a:latin typeface="Liberation Serif" pitchFamily="34" charset="0"/>
+                <a:ea typeface="Liberation Serif" pitchFamily="34" charset="-122"/>
+                <a:cs typeface="Liberation Serif" pitchFamily="34" charset="-120"/>
               </a:rPr>
               <a:t>What changed</a:t>
             </a:r>
@@ -2834,7 +3346,7 @@
                   <a:tcPr marL="109728" marR="109728" marT="109728" marB="109728" anchor="ctr">
                     <a:lnL w="9525" cap="flat" cmpd="sng" algn="ctr">
                       <a:solidFill>
-                        <a:srgbClr val="D5DDE8"/>
+                        <a:srgbClr val="EDE3CC"/>
                       </a:solidFill>
                       <a:prstDash val="solid"/>
                       <a:round/>
@@ -2843,7 +3355,7 @@
                     </a:lnL>
                     <a:lnR w="9525" cap="flat" cmpd="sng" algn="ctr">
                       <a:solidFill>
-                        <a:srgbClr val="D5DDE8"/>
+                        <a:srgbClr val="EDE3CC"/>
                       </a:solidFill>
                       <a:prstDash val="solid"/>
                       <a:round/>
@@ -2852,7 +3364,7 @@
                     </a:lnR>
                     <a:lnT w="9525" cap="flat" cmpd="sng" algn="ctr">
                       <a:solidFill>
-                        <a:srgbClr val="D5DDE8"/>
+                        <a:srgbClr val="EDE3CC"/>
                       </a:solidFill>
                       <a:prstDash val="solid"/>
                       <a:round/>
@@ -2861,7 +3373,7 @@
                     </a:lnT>
                     <a:lnB w="9525" cap="flat" cmpd="sng" algn="ctr">
                       <a:solidFill>
-                        <a:srgbClr val="D5DDE8"/>
+                        <a:srgbClr val="EDE3CC"/>
                       </a:solidFill>
                       <a:prstDash val="solid"/>
                       <a:round/>
@@ -2869,7 +3381,7 @@
                       <a:tailEnd type="none" w="med" len="med"/>
                     </a:lnB>
                     <a:solidFill>
-                      <a:srgbClr val="15253D"/>
+                      <a:srgbClr val="3A2A12"/>
                     </a:solidFill>
                   </a:tcPr>
                 </a:tc>
@@ -2902,7 +3414,7 @@
                   <a:tcPr marL="109728" marR="109728" marT="109728" marB="109728" anchor="ctr">
                     <a:lnL w="9525" cap="flat" cmpd="sng" algn="ctr">
                       <a:solidFill>
-                        <a:srgbClr val="D5DDE8"/>
+                        <a:srgbClr val="EDE3CC"/>
                       </a:solidFill>
                       <a:prstDash val="solid"/>
                       <a:round/>
@@ -2911,7 +3423,7 @@
                     </a:lnL>
                     <a:lnR w="9525" cap="flat" cmpd="sng" algn="ctr">
                       <a:solidFill>
-                        <a:srgbClr val="D5DDE8"/>
+                        <a:srgbClr val="EDE3CC"/>
                       </a:solidFill>
                       <a:prstDash val="solid"/>
                       <a:round/>
@@ -2920,7 +3432,7 @@
                     </a:lnR>
                     <a:lnT w="9525" cap="flat" cmpd="sng" algn="ctr">
                       <a:solidFill>
-                        <a:srgbClr val="D5DDE8"/>
+                        <a:srgbClr val="EDE3CC"/>
                       </a:solidFill>
                       <a:prstDash val="solid"/>
                       <a:round/>
@@ -2929,7 +3441,7 @@
                     </a:lnT>
                     <a:lnB w="9525" cap="flat" cmpd="sng" algn="ctr">
                       <a:solidFill>
-                        <a:srgbClr val="D5DDE8"/>
+                        <a:srgbClr val="EDE3CC"/>
                       </a:solidFill>
                       <a:prstDash val="solid"/>
                       <a:round/>
@@ -2937,7 +3449,7 @@
                       <a:tailEnd type="none" w="med" len="med"/>
                     </a:lnB>
                     <a:solidFill>
-                      <a:srgbClr val="15253D"/>
+                      <a:srgbClr val="3A2A12"/>
                     </a:solidFill>
                   </a:tcPr>
                 </a:tc>
@@ -2970,7 +3482,7 @@
                   <a:tcPr marL="109728" marR="109728" marT="109728" marB="109728" anchor="ctr">
                     <a:lnL w="9525" cap="flat" cmpd="sng" algn="ctr">
                       <a:solidFill>
-                        <a:srgbClr val="D5DDE8"/>
+                        <a:srgbClr val="EDE3CC"/>
                       </a:solidFill>
                       <a:prstDash val="solid"/>
                       <a:round/>
@@ -2979,7 +3491,7 @@
                     </a:lnL>
                     <a:lnR w="9525" cap="flat" cmpd="sng" algn="ctr">
                       <a:solidFill>
-                        <a:srgbClr val="D5DDE8"/>
+                        <a:srgbClr val="EDE3CC"/>
                       </a:solidFill>
                       <a:prstDash val="solid"/>
                       <a:round/>
@@ -2988,7 +3500,7 @@
                     </a:lnR>
                     <a:lnT w="9525" cap="flat" cmpd="sng" algn="ctr">
                       <a:solidFill>
-                        <a:srgbClr val="D5DDE8"/>
+                        <a:srgbClr val="EDE3CC"/>
                       </a:solidFill>
                       <a:prstDash val="solid"/>
                       <a:round/>
@@ -2997,7 +3509,7 @@
                     </a:lnT>
                     <a:lnB w="9525" cap="flat" cmpd="sng" algn="ctr">
                       <a:solidFill>
-                        <a:srgbClr val="D5DDE8"/>
+                        <a:srgbClr val="EDE3CC"/>
                       </a:solidFill>
                       <a:prstDash val="solid"/>
                       <a:round/>
@@ -3005,7 +3517,7 @@
                       <a:tailEnd type="none" w="med" len="med"/>
                     </a:lnB>
                     <a:solidFill>
-                      <a:srgbClr val="15253D"/>
+                      <a:srgbClr val="3A2A12"/>
                     </a:solidFill>
                   </a:tcPr>
                 </a:tc>
@@ -3022,7 +3534,7 @@
                       <a:r>
                         <a:rPr lang="en-US" sz="1500" b="1" dirty="0">
                           <a:solidFill>
-                            <a:srgbClr val="0F766E"/>
+                            <a:srgbClr val="9C7625"/>
                           </a:solidFill>
                           <a:latin typeface="Arial" pitchFamily="34" charset="0"/>
                           <a:ea typeface="Arial" pitchFamily="34" charset="-122"/>
@@ -3040,7 +3552,7 @@
                   <a:tcPr marL="109728" marR="109728" marT="109728" marB="109728" anchor="ctr">
                     <a:lnL w="9525" cap="flat" cmpd="sng" algn="ctr">
                       <a:solidFill>
-                        <a:srgbClr val="D5DDE8"/>
+                        <a:srgbClr val="EDE3CC"/>
                       </a:solidFill>
                       <a:prstDash val="solid"/>
                       <a:round/>
@@ -3049,7 +3561,7 @@
                     </a:lnL>
                     <a:lnR w="9525" cap="flat" cmpd="sng" algn="ctr">
                       <a:solidFill>
-                        <a:srgbClr val="D5DDE8"/>
+                        <a:srgbClr val="EDE3CC"/>
                       </a:solidFill>
                       <a:prstDash val="solid"/>
                       <a:round/>
@@ -3058,7 +3570,7 @@
                     </a:lnR>
                     <a:lnT w="9525" cap="flat" cmpd="sng" algn="ctr">
                       <a:solidFill>
-                        <a:srgbClr val="D5DDE8"/>
+                        <a:srgbClr val="EDE3CC"/>
                       </a:solidFill>
                       <a:prstDash val="solid"/>
                       <a:round/>
@@ -3067,7 +3579,7 @@
                     </a:lnT>
                     <a:lnB w="9525" cap="flat" cmpd="sng" algn="ctr">
                       <a:solidFill>
-                        <a:srgbClr val="D5DDE8"/>
+                        <a:srgbClr val="EDE3CC"/>
                       </a:solidFill>
                       <a:prstDash val="solid"/>
                       <a:round/>
@@ -3075,7 +3587,7 @@
                       <a:tailEnd type="none" w="med" len="med"/>
                     </a:lnB>
                     <a:solidFill>
-                      <a:srgbClr val="F4F7FB"/>
+                      <a:srgbClr val="FBF8F1"/>
                     </a:solidFill>
                   </a:tcPr>
                 </a:tc>
@@ -3108,7 +3620,7 @@
                   <a:tcPr marL="109728" marR="109728" marT="109728" marB="109728" anchor="ctr">
                     <a:lnL w="9525" cap="flat" cmpd="sng" algn="ctr">
                       <a:solidFill>
-                        <a:srgbClr val="D5DDE8"/>
+                        <a:srgbClr val="EDE3CC"/>
                       </a:solidFill>
                       <a:prstDash val="solid"/>
                       <a:round/>
@@ -3117,7 +3629,7 @@
                     </a:lnL>
                     <a:lnR w="9525" cap="flat" cmpd="sng" algn="ctr">
                       <a:solidFill>
-                        <a:srgbClr val="D5DDE8"/>
+                        <a:srgbClr val="EDE3CC"/>
                       </a:solidFill>
                       <a:prstDash val="solid"/>
                       <a:round/>
@@ -3126,7 +3638,7 @@
                     </a:lnR>
                     <a:lnT w="9525" cap="flat" cmpd="sng" algn="ctr">
                       <a:solidFill>
-                        <a:srgbClr val="D5DDE8"/>
+                        <a:srgbClr val="EDE3CC"/>
                       </a:solidFill>
                       <a:prstDash val="solid"/>
                       <a:round/>
@@ -3135,7 +3647,7 @@
                     </a:lnT>
                     <a:lnB w="9525" cap="flat" cmpd="sng" algn="ctr">
                       <a:solidFill>
-                        <a:srgbClr val="D5DDE8"/>
+                        <a:srgbClr val="EDE3CC"/>
                       </a:solidFill>
                       <a:prstDash val="solid"/>
                       <a:round/>
@@ -3143,7 +3655,7 @@
                       <a:tailEnd type="none" w="med" len="med"/>
                     </a:lnB>
                     <a:solidFill>
-                      <a:srgbClr val="F4F7FB"/>
+                      <a:srgbClr val="FBF8F1"/>
                     </a:solidFill>
                   </a:tcPr>
                 </a:tc>
@@ -3176,7 +3688,7 @@
                   <a:tcPr marL="109728" marR="109728" marT="109728" marB="109728" anchor="ctr">
                     <a:lnL w="9525" cap="flat" cmpd="sng" algn="ctr">
                       <a:solidFill>
-                        <a:srgbClr val="D5DDE8"/>
+                        <a:srgbClr val="EDE3CC"/>
                       </a:solidFill>
                       <a:prstDash val="solid"/>
                       <a:round/>
@@ -3185,7 +3697,7 @@
                     </a:lnL>
                     <a:lnR w="9525" cap="flat" cmpd="sng" algn="ctr">
                       <a:solidFill>
-                        <a:srgbClr val="D5DDE8"/>
+                        <a:srgbClr val="EDE3CC"/>
                       </a:solidFill>
                       <a:prstDash val="solid"/>
                       <a:round/>
@@ -3194,7 +3706,7 @@
                     </a:lnR>
                     <a:lnT w="9525" cap="flat" cmpd="sng" algn="ctr">
                       <a:solidFill>
-                        <a:srgbClr val="D5DDE8"/>
+                        <a:srgbClr val="EDE3CC"/>
                       </a:solidFill>
                       <a:prstDash val="solid"/>
                       <a:round/>
@@ -3203,7 +3715,7 @@
                     </a:lnT>
                     <a:lnB w="9525" cap="flat" cmpd="sng" algn="ctr">
                       <a:solidFill>
-                        <a:srgbClr val="D5DDE8"/>
+                        <a:srgbClr val="EDE3CC"/>
                       </a:solidFill>
                       <a:prstDash val="solid"/>
                       <a:round/>
@@ -3211,7 +3723,7 @@
                       <a:tailEnd type="none" w="med" len="med"/>
                     </a:lnB>
                     <a:solidFill>
-                      <a:srgbClr val="F4F7FB"/>
+                      <a:srgbClr val="FBF8F1"/>
                     </a:solidFill>
                   </a:tcPr>
                 </a:tc>
@@ -3228,7 +3740,7 @@
                       <a:r>
                         <a:rPr lang="en-US" sz="1500" b="1" dirty="0">
                           <a:solidFill>
-                            <a:srgbClr val="0F766E"/>
+                            <a:srgbClr val="9C7625"/>
                           </a:solidFill>
                           <a:latin typeface="Arial" pitchFamily="34" charset="0"/>
                           <a:ea typeface="Arial" pitchFamily="34" charset="-122"/>
@@ -3246,7 +3758,7 @@
                   <a:tcPr marL="109728" marR="109728" marT="109728" marB="109728" anchor="ctr">
                     <a:lnL w="9525" cap="flat" cmpd="sng" algn="ctr">
                       <a:solidFill>
-                        <a:srgbClr val="D5DDE8"/>
+                        <a:srgbClr val="EDE3CC"/>
                       </a:solidFill>
                       <a:prstDash val="solid"/>
                       <a:round/>
@@ -3255,7 +3767,7 @@
                     </a:lnL>
                     <a:lnR w="9525" cap="flat" cmpd="sng" algn="ctr">
                       <a:solidFill>
-                        <a:srgbClr val="D5DDE8"/>
+                        <a:srgbClr val="EDE3CC"/>
                       </a:solidFill>
                       <a:prstDash val="solid"/>
                       <a:round/>
@@ -3264,7 +3776,7 @@
                     </a:lnR>
                     <a:lnT w="9525" cap="flat" cmpd="sng" algn="ctr">
                       <a:solidFill>
-                        <a:srgbClr val="D5DDE8"/>
+                        <a:srgbClr val="EDE3CC"/>
                       </a:solidFill>
                       <a:prstDash val="solid"/>
                       <a:round/>
@@ -3273,7 +3785,7 @@
                     </a:lnT>
                     <a:lnB w="9525" cap="flat" cmpd="sng" algn="ctr">
                       <a:solidFill>
-                        <a:srgbClr val="D5DDE8"/>
+                        <a:srgbClr val="EDE3CC"/>
                       </a:solidFill>
                       <a:prstDash val="solid"/>
                       <a:round/>
@@ -3314,7 +3826,7 @@
                   <a:tcPr marL="109728" marR="109728" marT="109728" marB="109728" anchor="ctr">
                     <a:lnL w="9525" cap="flat" cmpd="sng" algn="ctr">
                       <a:solidFill>
-                        <a:srgbClr val="D5DDE8"/>
+                        <a:srgbClr val="EDE3CC"/>
                       </a:solidFill>
                       <a:prstDash val="solid"/>
                       <a:round/>
@@ -3323,7 +3835,7 @@
                     </a:lnL>
                     <a:lnR w="9525" cap="flat" cmpd="sng" algn="ctr">
                       <a:solidFill>
-                        <a:srgbClr val="D5DDE8"/>
+                        <a:srgbClr val="EDE3CC"/>
                       </a:solidFill>
                       <a:prstDash val="solid"/>
                       <a:round/>
@@ -3332,7 +3844,7 @@
                     </a:lnR>
                     <a:lnT w="9525" cap="flat" cmpd="sng" algn="ctr">
                       <a:solidFill>
-                        <a:srgbClr val="D5DDE8"/>
+                        <a:srgbClr val="EDE3CC"/>
                       </a:solidFill>
                       <a:prstDash val="solid"/>
                       <a:round/>
@@ -3341,7 +3853,7 @@
                     </a:lnT>
                     <a:lnB w="9525" cap="flat" cmpd="sng" algn="ctr">
                       <a:solidFill>
-                        <a:srgbClr val="D5DDE8"/>
+                        <a:srgbClr val="EDE3CC"/>
                       </a:solidFill>
                       <a:prstDash val="solid"/>
                       <a:round/>
@@ -3382,7 +3894,7 @@
                   <a:tcPr marL="109728" marR="109728" marT="109728" marB="109728" anchor="ctr">
                     <a:lnL w="9525" cap="flat" cmpd="sng" algn="ctr">
                       <a:solidFill>
-                        <a:srgbClr val="D5DDE8"/>
+                        <a:srgbClr val="EDE3CC"/>
                       </a:solidFill>
                       <a:prstDash val="solid"/>
                       <a:round/>
@@ -3391,7 +3903,7 @@
                     </a:lnL>
                     <a:lnR w="9525" cap="flat" cmpd="sng" algn="ctr">
                       <a:solidFill>
-                        <a:srgbClr val="D5DDE8"/>
+                        <a:srgbClr val="EDE3CC"/>
                       </a:solidFill>
                       <a:prstDash val="solid"/>
                       <a:round/>
@@ -3400,7 +3912,7 @@
                     </a:lnR>
                     <a:lnT w="9525" cap="flat" cmpd="sng" algn="ctr">
                       <a:solidFill>
-                        <a:srgbClr val="D5DDE8"/>
+                        <a:srgbClr val="EDE3CC"/>
                       </a:solidFill>
                       <a:prstDash val="solid"/>
                       <a:round/>
@@ -3409,7 +3921,7 @@
                     </a:lnT>
                     <a:lnB w="9525" cap="flat" cmpd="sng" algn="ctr">
                       <a:solidFill>
-                        <a:srgbClr val="D5DDE8"/>
+                        <a:srgbClr val="EDE3CC"/>
                       </a:solidFill>
                       <a:prstDash val="solid"/>
                       <a:round/>
@@ -3434,7 +3946,7 @@
                       <a:r>
                         <a:rPr lang="en-US" sz="1500" b="1" dirty="0">
                           <a:solidFill>
-                            <a:srgbClr val="0F766E"/>
+                            <a:srgbClr val="9C7625"/>
                           </a:solidFill>
                           <a:latin typeface="Arial" pitchFamily="34" charset="0"/>
                           <a:ea typeface="Arial" pitchFamily="34" charset="-122"/>
@@ -3452,7 +3964,7 @@
                   <a:tcPr marL="109728" marR="109728" marT="109728" marB="109728" anchor="ctr">
                     <a:lnL w="9525" cap="flat" cmpd="sng" algn="ctr">
                       <a:solidFill>
-                        <a:srgbClr val="D5DDE8"/>
+                        <a:srgbClr val="EDE3CC"/>
                       </a:solidFill>
                       <a:prstDash val="solid"/>
                       <a:round/>
@@ -3461,7 +3973,7 @@
                     </a:lnL>
                     <a:lnR w="9525" cap="flat" cmpd="sng" algn="ctr">
                       <a:solidFill>
-                        <a:srgbClr val="D5DDE8"/>
+                        <a:srgbClr val="EDE3CC"/>
                       </a:solidFill>
                       <a:prstDash val="solid"/>
                       <a:round/>
@@ -3470,7 +3982,7 @@
                     </a:lnR>
                     <a:lnT w="9525" cap="flat" cmpd="sng" algn="ctr">
                       <a:solidFill>
-                        <a:srgbClr val="D5DDE8"/>
+                        <a:srgbClr val="EDE3CC"/>
                       </a:solidFill>
                       <a:prstDash val="solid"/>
                       <a:round/>
@@ -3479,7 +3991,7 @@
                     </a:lnT>
                     <a:lnB w="9525" cap="flat" cmpd="sng" algn="ctr">
                       <a:solidFill>
-                        <a:srgbClr val="D5DDE8"/>
+                        <a:srgbClr val="EDE3CC"/>
                       </a:solidFill>
                       <a:prstDash val="solid"/>
                       <a:round/>
@@ -3487,7 +3999,7 @@
                       <a:tailEnd type="none" w="med" len="med"/>
                     </a:lnB>
                     <a:solidFill>
-                      <a:srgbClr val="F4F7FB"/>
+                      <a:srgbClr val="FBF8F1"/>
                     </a:solidFill>
                   </a:tcPr>
                 </a:tc>
@@ -3520,7 +4032,7 @@
                   <a:tcPr marL="109728" marR="109728" marT="109728" marB="109728" anchor="ctr">
                     <a:lnL w="9525" cap="flat" cmpd="sng" algn="ctr">
                       <a:solidFill>
-                        <a:srgbClr val="D5DDE8"/>
+                        <a:srgbClr val="EDE3CC"/>
                       </a:solidFill>
                       <a:prstDash val="solid"/>
                       <a:round/>
@@ -3529,7 +4041,7 @@
                     </a:lnL>
                     <a:lnR w="9525" cap="flat" cmpd="sng" algn="ctr">
                       <a:solidFill>
-                        <a:srgbClr val="D5DDE8"/>
+                        <a:srgbClr val="EDE3CC"/>
                       </a:solidFill>
                       <a:prstDash val="solid"/>
                       <a:round/>
@@ -3538,7 +4050,7 @@
                     </a:lnR>
                     <a:lnT w="9525" cap="flat" cmpd="sng" algn="ctr">
                       <a:solidFill>
-                        <a:srgbClr val="D5DDE8"/>
+                        <a:srgbClr val="EDE3CC"/>
                       </a:solidFill>
                       <a:prstDash val="solid"/>
                       <a:round/>
@@ -3547,7 +4059,7 @@
                     </a:lnT>
                     <a:lnB w="9525" cap="flat" cmpd="sng" algn="ctr">
                       <a:solidFill>
-                        <a:srgbClr val="D5DDE8"/>
+                        <a:srgbClr val="EDE3CC"/>
                       </a:solidFill>
                       <a:prstDash val="solid"/>
                       <a:round/>
@@ -3555,7 +4067,7 @@
                       <a:tailEnd type="none" w="med" len="med"/>
                     </a:lnB>
                     <a:solidFill>
-                      <a:srgbClr val="F4F7FB"/>
+                      <a:srgbClr val="FBF8F1"/>
                     </a:solidFill>
                   </a:tcPr>
                 </a:tc>
@@ -3588,7 +4100,7 @@
                   <a:tcPr marL="109728" marR="109728" marT="109728" marB="109728" anchor="ctr">
                     <a:lnL w="9525" cap="flat" cmpd="sng" algn="ctr">
                       <a:solidFill>
-                        <a:srgbClr val="D5DDE8"/>
+                        <a:srgbClr val="EDE3CC"/>
                       </a:solidFill>
                       <a:prstDash val="solid"/>
                       <a:round/>
@@ -3597,7 +4109,7 @@
                     </a:lnL>
                     <a:lnR w="9525" cap="flat" cmpd="sng" algn="ctr">
                       <a:solidFill>
-                        <a:srgbClr val="D5DDE8"/>
+                        <a:srgbClr val="EDE3CC"/>
                       </a:solidFill>
                       <a:prstDash val="solid"/>
                       <a:round/>
@@ -3606,7 +4118,7 @@
                     </a:lnR>
                     <a:lnT w="9525" cap="flat" cmpd="sng" algn="ctr">
                       <a:solidFill>
-                        <a:srgbClr val="D5DDE8"/>
+                        <a:srgbClr val="EDE3CC"/>
                       </a:solidFill>
                       <a:prstDash val="solid"/>
                       <a:round/>
@@ -3615,7 +4127,7 @@
                     </a:lnT>
                     <a:lnB w="9525" cap="flat" cmpd="sng" algn="ctr">
                       <a:solidFill>
-                        <a:srgbClr val="D5DDE8"/>
+                        <a:srgbClr val="EDE3CC"/>
                       </a:solidFill>
                       <a:prstDash val="solid"/>
                       <a:round/>
@@ -3623,7 +4135,7 @@
                       <a:tailEnd type="none" w="med" len="med"/>
                     </a:lnB>
                     <a:solidFill>
-                      <a:srgbClr val="F4F7FB"/>
+                      <a:srgbClr val="FBF8F1"/>
                     </a:solidFill>
                   </a:tcPr>
                 </a:tc>
@@ -3640,7 +4152,7 @@
                       <a:r>
                         <a:rPr lang="en-US" sz="1500" b="1" dirty="0">
                           <a:solidFill>
-                            <a:srgbClr val="0F766E"/>
+                            <a:srgbClr val="9C7625"/>
                           </a:solidFill>
                           <a:latin typeface="Arial" pitchFamily="34" charset="0"/>
                           <a:ea typeface="Arial" pitchFamily="34" charset="-122"/>
@@ -3658,7 +4170,7 @@
                   <a:tcPr marL="109728" marR="109728" marT="109728" marB="109728" anchor="ctr">
                     <a:lnL w="9525" cap="flat" cmpd="sng" algn="ctr">
                       <a:solidFill>
-                        <a:srgbClr val="D5DDE8"/>
+                        <a:srgbClr val="EDE3CC"/>
                       </a:solidFill>
                       <a:prstDash val="solid"/>
                       <a:round/>
@@ -3667,7 +4179,7 @@
                     </a:lnL>
                     <a:lnR w="9525" cap="flat" cmpd="sng" algn="ctr">
                       <a:solidFill>
-                        <a:srgbClr val="D5DDE8"/>
+                        <a:srgbClr val="EDE3CC"/>
                       </a:solidFill>
                       <a:prstDash val="solid"/>
                       <a:round/>
@@ -3676,7 +4188,7 @@
                     </a:lnR>
                     <a:lnT w="9525" cap="flat" cmpd="sng" algn="ctr">
                       <a:solidFill>
-                        <a:srgbClr val="D5DDE8"/>
+                        <a:srgbClr val="EDE3CC"/>
                       </a:solidFill>
                       <a:prstDash val="solid"/>
                       <a:round/>
@@ -3685,7 +4197,7 @@
                     </a:lnT>
                     <a:lnB w="9525" cap="flat" cmpd="sng" algn="ctr">
                       <a:solidFill>
-                        <a:srgbClr val="D5DDE8"/>
+                        <a:srgbClr val="EDE3CC"/>
                       </a:solidFill>
                       <a:prstDash val="solid"/>
                       <a:round/>
@@ -3726,7 +4238,7 @@
                   <a:tcPr marL="109728" marR="109728" marT="109728" marB="109728" anchor="ctr">
                     <a:lnL w="9525" cap="flat" cmpd="sng" algn="ctr">
                       <a:solidFill>
-                        <a:srgbClr val="D5DDE8"/>
+                        <a:srgbClr val="EDE3CC"/>
                       </a:solidFill>
                       <a:prstDash val="solid"/>
                       <a:round/>
@@ -3735,7 +4247,7 @@
                     </a:lnL>
                     <a:lnR w="9525" cap="flat" cmpd="sng" algn="ctr">
                       <a:solidFill>
-                        <a:srgbClr val="D5DDE8"/>
+                        <a:srgbClr val="EDE3CC"/>
                       </a:solidFill>
                       <a:prstDash val="solid"/>
                       <a:round/>
@@ -3744,7 +4256,7 @@
                     </a:lnR>
                     <a:lnT w="9525" cap="flat" cmpd="sng" algn="ctr">
                       <a:solidFill>
-                        <a:srgbClr val="D5DDE8"/>
+                        <a:srgbClr val="EDE3CC"/>
                       </a:solidFill>
                       <a:prstDash val="solid"/>
                       <a:round/>
@@ -3753,7 +4265,7 @@
                     </a:lnT>
                     <a:lnB w="9525" cap="flat" cmpd="sng" algn="ctr">
                       <a:solidFill>
-                        <a:srgbClr val="D5DDE8"/>
+                        <a:srgbClr val="EDE3CC"/>
                       </a:solidFill>
                       <a:prstDash val="solid"/>
                       <a:round/>
@@ -3794,7 +4306,7 @@
                   <a:tcPr marL="109728" marR="109728" marT="109728" marB="109728" anchor="ctr">
                     <a:lnL w="9525" cap="flat" cmpd="sng" algn="ctr">
                       <a:solidFill>
-                        <a:srgbClr val="D5DDE8"/>
+                        <a:srgbClr val="EDE3CC"/>
                       </a:solidFill>
                       <a:prstDash val="solid"/>
                       <a:round/>
@@ -3803,7 +4315,7 @@
                     </a:lnL>
                     <a:lnR w="9525" cap="flat" cmpd="sng" algn="ctr">
                       <a:solidFill>
-                        <a:srgbClr val="D5DDE8"/>
+                        <a:srgbClr val="EDE3CC"/>
                       </a:solidFill>
                       <a:prstDash val="solid"/>
                       <a:round/>
@@ -3812,7 +4324,7 @@
                     </a:lnR>
                     <a:lnT w="9525" cap="flat" cmpd="sng" algn="ctr">
                       <a:solidFill>
-                        <a:srgbClr val="D5DDE8"/>
+                        <a:srgbClr val="EDE3CC"/>
                       </a:solidFill>
                       <a:prstDash val="solid"/>
                       <a:round/>
@@ -3821,7 +4333,7 @@
                     </a:lnT>
                     <a:lnB w="9525" cap="flat" cmpd="sng" algn="ctr">
                       <a:solidFill>
-                        <a:srgbClr val="D5DDE8"/>
+                        <a:srgbClr val="EDE3CC"/>
                       </a:solidFill>
                       <a:prstDash val="solid"/>
                       <a:round/>
@@ -3913,6 +4425,129 @@
               <a:t>05</a:t>
             </a:r>
             <a:endParaRPr lang="en-US" sz="900" dirty="0"/>
+          </a:p>
+        </p:txBody>
+      </p:sp>
+      <p:sp>
+        <p:nvSpPr>
+          <p:cNvPr id="7" name="Rectangle 6"/>
+          <p:cNvSpPr/>
+          <p:nvPr/>
+        </p:nvSpPr>
+        <p:spPr>
+          <a:xfrm>
+            <a:off x="0" y="0"/>
+            <a:ext cx="12192000" cy="82296"/>
+          </a:xfrm>
+          <a:prstGeom prst="rect">
+            <a:avLst/>
+          </a:prstGeom>
+          <a:solidFill>
+            <a:srgbClr val="3A2A12"/>
+          </a:solidFill>
+          <a:ln>
+            <a:noFill/>
+          </a:ln>
+          <a:effectLst/>
+        </p:spPr>
+        <p:style>
+          <a:lnRef idx="1">
+            <a:schemeClr val="accent1"/>
+          </a:lnRef>
+          <a:fillRef idx="3">
+            <a:schemeClr val="accent1"/>
+          </a:fillRef>
+          <a:effectRef idx="2">
+            <a:schemeClr val="accent1"/>
+          </a:effectRef>
+          <a:fontRef idx="minor">
+            <a:schemeClr val="lt1"/>
+          </a:fontRef>
+        </p:style>
+        <p:txBody>
+          <a:bodyPr rtlCol="0" anchor="ctr"/>
+          <a:lstStyle/>
+          <a:p>
+            <a:pPr algn="ctr"/>
+          </a:p>
+        </p:txBody>
+      </p:sp>
+      <p:sp>
+        <p:nvSpPr>
+          <p:cNvPr id="8" name="Rectangle 7"/>
+          <p:cNvSpPr/>
+          <p:nvPr/>
+        </p:nvSpPr>
+        <p:spPr>
+          <a:xfrm>
+            <a:off x="0" y="82296"/>
+            <a:ext cx="1463040" cy="45720"/>
+          </a:xfrm>
+          <a:prstGeom prst="rect">
+            <a:avLst/>
+          </a:prstGeom>
+          <a:solidFill>
+            <a:srgbClr val="C9A24A"/>
+          </a:solidFill>
+          <a:ln>
+            <a:noFill/>
+          </a:ln>
+          <a:effectLst/>
+        </p:spPr>
+        <p:style>
+          <a:lnRef idx="1">
+            <a:schemeClr val="accent1"/>
+          </a:lnRef>
+          <a:fillRef idx="3">
+            <a:schemeClr val="accent1"/>
+          </a:fillRef>
+          <a:effectRef idx="2">
+            <a:schemeClr val="accent1"/>
+          </a:effectRef>
+          <a:fontRef idx="minor">
+            <a:schemeClr val="lt1"/>
+          </a:fontRef>
+        </p:style>
+        <p:txBody>
+          <a:bodyPr rtlCol="0" anchor="ctr"/>
+          <a:lstStyle/>
+          <a:p>
+            <a:pPr algn="ctr"/>
+          </a:p>
+        </p:txBody>
+      </p:sp>
+      <p:sp>
+        <p:nvSpPr>
+          <p:cNvPr id="9" name="TextBox 8"/>
+          <p:cNvSpPr txBox="1"/>
+          <p:nvPr/>
+        </p:nvSpPr>
+        <p:spPr>
+          <a:xfrm>
+            <a:off x="10088880" y="6327648"/>
+            <a:ext cx="1463040" cy="384048"/>
+          </a:xfrm>
+          <a:prstGeom prst="rect">
+            <a:avLst/>
+          </a:prstGeom>
+          <a:noFill/>
+        </p:spPr>
+        <p:txBody>
+          <a:bodyPr wrap="none" anchor="ctr">
+            <a:spAutoFit/>
+          </a:bodyPr>
+          <a:lstStyle/>
+          <a:p>
+            <a:pPr algn="ctr"/>
+            <a:r>
+              <a:rPr sz="1300" b="1">
+                <a:solidFill>
+                  <a:srgbClr val="3A2A12"/>
+                </a:solidFill>
+                <a:latin typeface="Liberation Serif"/>
+              </a:rPr>
+              <a:t>BOZ</a:t>
+            </a:r>
           </a:p>
         </p:txBody>
       </p:sp>
@@ -3975,28 +4610,96 @@
             <a:r>
               <a:rPr lang="en-US" sz="2600" b="1" dirty="0">
                 <a:solidFill>
-                  <a:srgbClr val="15253D"/>
+                  <a:srgbClr val="3A2A12"/>
+                </a:solidFill>
+                <a:latin typeface="Liberation Serif" pitchFamily="34" charset="0"/>
+                <a:ea typeface="Liberation Serif" pitchFamily="34" charset="-122"/>
+                <a:cs typeface="Liberation Serif" pitchFamily="34" charset="-120"/>
+              </a:rPr>
+              <a:t>Reported outcomes</a:t>
+            </a:r>
+            <a:endParaRPr lang="en-US" sz="2600" dirty="0"/>
+          </a:p>
+        </p:txBody>
+      </p:sp>
+      <p:sp>
+        <p:nvSpPr>
+          <p:cNvPr id="3" name="Text 1"/>
+          <p:cNvSpPr txBox="1"/>
+          <p:nvPr/>
+        </p:nvSpPr>
+        <p:spPr>
+          <a:xfrm>
+            <a:off x="457200" y="868680"/>
+            <a:ext cx="11247120" cy="320040"/>
+          </a:xfrm>
+          <a:prstGeom prst="rect">
+            <a:avLst/>
+          </a:prstGeom>
+          <a:noFill/>
+          <a:ln/>
+        </p:spPr>
+        <p:txBody>
+          <a:bodyPr wrap="square" lIns="0" tIns="0" rIns="0" bIns="0" rtlCol="0" anchor="ctr"/>
+          <a:lstStyle/>
+          <a:p>
+            <a:pPr indent="0" marL="0">
+              <a:buNone/>
+            </a:pPr>
+            <a:r>
+              <a:rPr lang="en-US" sz="1300" dirty="0">
+                <a:solidFill>
+                  <a:srgbClr val="64748B"/>
                 </a:solidFill>
                 <a:latin typeface="Arial" pitchFamily="34" charset="0"/>
                 <a:ea typeface="Arial" pitchFamily="34" charset="-122"/>
                 <a:cs typeface="Arial" pitchFamily="34" charset="-120"/>
               </a:rPr>
-              <a:t>Reported outcomes</a:t>
-            </a:r>
-            <a:endParaRPr lang="en-US" sz="2600" dirty="0"/>
-          </a:p>
-        </p:txBody>
-      </p:sp>
-      <p:sp>
-        <p:nvSpPr>
-          <p:cNvPr id="3" name="Text 1"/>
+              <a:t>Figures reported by the organisation after the changes; underlying commercial data is not published</a:t>
+            </a:r>
+            <a:endParaRPr lang="en-US" sz="1300" dirty="0"/>
+          </a:p>
+        </p:txBody>
+      </p:sp>
+      <p:sp>
+        <p:nvSpPr>
+          <p:cNvPr id="4" name="Shape 2"/>
+          <p:cNvSpPr/>
+          <p:nvPr/>
+        </p:nvSpPr>
+        <p:spPr>
+          <a:xfrm>
+            <a:off x="457200" y="1737360"/>
+            <a:ext cx="5486400" cy="3108960"/>
+          </a:xfrm>
+          <a:prstGeom prst="rect">
+            <a:avLst/>
+          </a:prstGeom>
+          <a:solidFill>
+            <a:srgbClr val="FBF8F1"/>
+          </a:solidFill>
+          <a:ln w="12700">
+            <a:solidFill>
+              <a:srgbClr val="FBF8F1"/>
+            </a:solidFill>
+            <a:prstDash val="solid"/>
+          </a:ln>
+        </p:spPr>
+        <p:txBody>
+          <a:bodyPr/>
+          <a:p/>
+        </p:txBody>
+      </p:sp>
+      <p:sp>
+        <p:nvSpPr>
+          <p:cNvPr id="5" name="Text 3"/>
           <p:cNvSpPr txBox="1"/>
           <p:nvPr/>
         </p:nvSpPr>
         <p:spPr>
           <a:xfrm>
-            <a:off x="457200" y="868680"/>
-            <a:ext cx="11247120" cy="320040"/>
+            <a:off x="822960" y="2011680"/>
+            <a:ext cx="4754880" cy="1463040"/>
           </a:xfrm>
           <a:prstGeom prst="rect">
             <a:avLst/>
@@ -4012,54 +4715,97 @@
               <a:buNone/>
             </a:pPr>
             <a:r>
-              <a:rPr lang="en-US" sz="1300" dirty="0">
-                <a:solidFill>
-                  <a:srgbClr val="64748B"/>
+              <a:rPr lang="en-US" sz="7200" b="1" dirty="0">
+                <a:solidFill>
+                  <a:srgbClr val="9C7625"/>
+                </a:solidFill>
+                <a:latin typeface="Liberation Serif" pitchFamily="34" charset="0"/>
+                <a:ea typeface="Liberation Serif" pitchFamily="34" charset="-122"/>
+                <a:cs typeface="Liberation Serif" pitchFamily="34" charset="-120"/>
+              </a:rPr>
+              <a:t>60%</a:t>
+            </a:r>
+            <a:endParaRPr lang="en-US" sz="7200" dirty="0"/>
+          </a:p>
+        </p:txBody>
+      </p:sp>
+      <p:sp>
+        <p:nvSpPr>
+          <p:cNvPr id="6" name="Text 4"/>
+          <p:cNvSpPr txBox="1"/>
+          <p:nvPr/>
+        </p:nvSpPr>
+        <p:spPr>
+          <a:xfrm>
+            <a:off x="822960" y="3566160"/>
+            <a:ext cx="4754880" cy="914400"/>
+          </a:xfrm>
+          <a:prstGeom prst="rect">
+            <a:avLst/>
+          </a:prstGeom>
+          <a:noFill/>
+          <a:ln/>
+        </p:spPr>
+        <p:txBody>
+          <a:bodyPr wrap="square" lIns="0" tIns="0" rIns="0" bIns="0" rtlCol="0" anchor="t"/>
+          <a:lstStyle/>
+          <a:p>
+            <a:pPr indent="0" marL="0">
+              <a:buNone/>
+            </a:pPr>
+            <a:r>
+              <a:rPr lang="en-US" sz="1800" dirty="0">
+                <a:solidFill>
+                  <a:srgbClr val="1E293B"/>
                 </a:solidFill>
                 <a:latin typeface="Arial" pitchFamily="34" charset="0"/>
                 <a:ea typeface="Arial" pitchFamily="34" charset="-122"/>
                 <a:cs typeface="Arial" pitchFamily="34" charset="-120"/>
               </a:rPr>
-              <a:t>Figures reported by the organisation after the changes; underlying commercial data is not published</a:t>
-            </a:r>
-            <a:endParaRPr lang="en-US" sz="1300" dirty="0"/>
-          </a:p>
-        </p:txBody>
-      </p:sp>
-      <p:sp>
-        <p:nvSpPr>
-          <p:cNvPr id="4" name="Shape 2"/>
+              <a:t>increase in engagement (reported)</a:t>
+            </a:r>
+            <a:endParaRPr lang="en-US" sz="1800" dirty="0"/>
+          </a:p>
+        </p:txBody>
+      </p:sp>
+      <p:sp>
+        <p:nvSpPr>
+          <p:cNvPr id="7" name="Shape 5"/>
           <p:cNvSpPr/>
           <p:nvPr/>
         </p:nvSpPr>
         <p:spPr>
           <a:xfrm>
-            <a:off x="457200" y="1737360"/>
+            <a:off x="6172200" y="1737360"/>
             <a:ext cx="5486400" cy="3108960"/>
           </a:xfrm>
           <a:prstGeom prst="rect">
             <a:avLst/>
           </a:prstGeom>
           <a:solidFill>
-            <a:srgbClr val="F4F7FB"/>
+            <a:srgbClr val="FBF8F1"/>
           </a:solidFill>
           <a:ln w="12700">
             <a:solidFill>
-              <a:srgbClr val="F4F7FB"/>
+              <a:srgbClr val="FBF8F1"/>
             </a:solidFill>
             <a:prstDash val="solid"/>
           </a:ln>
         </p:spPr>
-      </p:sp>
-      <p:sp>
-        <p:nvSpPr>
-          <p:cNvPr id="5" name="Text 3"/>
+        <p:txBody>
+          <a:bodyPr/>
+          <a:p/>
+        </p:txBody>
+      </p:sp>
+      <p:sp>
+        <p:nvSpPr>
+          <p:cNvPr id="8" name="Text 6"/>
           <p:cNvSpPr txBox="1"/>
           <p:nvPr/>
         </p:nvSpPr>
         <p:spPr>
           <a:xfrm>
-            <a:off x="822960" y="2011680"/>
+            <a:off x="6537960" y="2011680"/>
             <a:ext cx="4754880" cy="1463040"/>
           </a:xfrm>
           <a:prstGeom prst="rect">
@@ -4078,28 +4824,67 @@
             <a:r>
               <a:rPr lang="en-US" sz="7200" b="1" dirty="0">
                 <a:solidFill>
-                  <a:srgbClr val="0F766E"/>
+                  <a:srgbClr val="9C7625"/>
+                </a:solidFill>
+                <a:latin typeface="Liberation Serif" pitchFamily="34" charset="0"/>
+                <a:ea typeface="Liberation Serif" pitchFamily="34" charset="-122"/>
+                <a:cs typeface="Liberation Serif" pitchFamily="34" charset="-120"/>
+              </a:rPr>
+              <a:t>25%</a:t>
+            </a:r>
+            <a:endParaRPr lang="en-US" sz="7200" dirty="0"/>
+          </a:p>
+        </p:txBody>
+      </p:sp>
+      <p:sp>
+        <p:nvSpPr>
+          <p:cNvPr id="9" name="Text 7"/>
+          <p:cNvSpPr txBox="1"/>
+          <p:nvPr/>
+        </p:nvSpPr>
+        <p:spPr>
+          <a:xfrm>
+            <a:off x="6537960" y="3566160"/>
+            <a:ext cx="4754880" cy="914400"/>
+          </a:xfrm>
+          <a:prstGeom prst="rect">
+            <a:avLst/>
+          </a:prstGeom>
+          <a:noFill/>
+          <a:ln/>
+        </p:spPr>
+        <p:txBody>
+          <a:bodyPr wrap="square" lIns="0" tIns="0" rIns="0" bIns="0" rtlCol="0" anchor="t"/>
+          <a:lstStyle/>
+          <a:p>
+            <a:pPr indent="0" marL="0">
+              <a:buNone/>
+            </a:pPr>
+            <a:r>
+              <a:rPr lang="en-US" sz="1800" dirty="0">
+                <a:solidFill>
+                  <a:srgbClr val="1E293B"/>
                 </a:solidFill>
                 <a:latin typeface="Arial" pitchFamily="34" charset="0"/>
                 <a:ea typeface="Arial" pitchFamily="34" charset="-122"/>
                 <a:cs typeface="Arial" pitchFamily="34" charset="-120"/>
               </a:rPr>
-              <a:t>60%</a:t>
-            </a:r>
-            <a:endParaRPr lang="en-US" sz="7200" dirty="0"/>
-          </a:p>
-        </p:txBody>
-      </p:sp>
-      <p:sp>
-        <p:nvSpPr>
-          <p:cNvPr id="6" name="Text 4"/>
+              <a:t>uplift in digital performance (reported)</a:t>
+            </a:r>
+            <a:endParaRPr lang="en-US" sz="1800" dirty="0"/>
+          </a:p>
+        </p:txBody>
+      </p:sp>
+      <p:sp>
+        <p:nvSpPr>
+          <p:cNvPr id="10" name="Text 8"/>
           <p:cNvSpPr txBox="1"/>
           <p:nvPr/>
         </p:nvSpPr>
         <p:spPr>
           <a:xfrm>
-            <a:off x="822960" y="3566160"/>
-            <a:ext cx="4754880" cy="914400"/>
+            <a:off x="457200" y="6446520"/>
+            <a:ext cx="8229600" cy="274320"/>
           </a:xfrm>
           <a:prstGeom prst="rect">
             <a:avLst/>
@@ -4108,62 +4893,37 @@
           <a:ln/>
         </p:spPr>
         <p:txBody>
-          <a:bodyPr wrap="square" lIns="0" tIns="0" rIns="0" bIns="0" rtlCol="0" anchor="t"/>
+          <a:bodyPr wrap="square" lIns="0" tIns="0" rIns="0" bIns="0" rtlCol="0" anchor="ctr"/>
           <a:lstStyle/>
           <a:p>
             <a:pPr indent="0" marL="0">
               <a:buNone/>
             </a:pPr>
             <a:r>
-              <a:rPr lang="en-US" sz="1800" dirty="0">
-                <a:solidFill>
-                  <a:srgbClr val="1E293B"/>
+              <a:rPr lang="en-US" sz="900" dirty="0">
+                <a:solidFill>
+                  <a:srgbClr val="64748B"/>
                 </a:solidFill>
                 <a:latin typeface="Arial" pitchFamily="34" charset="0"/>
                 <a:ea typeface="Arial" pitchFamily="34" charset="-122"/>
                 <a:cs typeface="Arial" pitchFamily="34" charset="-120"/>
               </a:rPr>
-              <a:t>increase in engagement (reported)</a:t>
-            </a:r>
-            <a:endParaRPr lang="en-US" sz="1800" dirty="0"/>
-          </a:p>
-        </p:txBody>
-      </p:sp>
-      <p:sp>
-        <p:nvSpPr>
-          <p:cNvPr id="7" name="Shape 5"/>
-          <p:cNvSpPr/>
-          <p:nvPr/>
-        </p:nvSpPr>
-        <p:spPr>
-          <a:xfrm>
-            <a:off x="6172200" y="1737360"/>
-            <a:ext cx="5486400" cy="3108960"/>
-          </a:xfrm>
-          <a:prstGeom prst="rect">
-            <a:avLst/>
-          </a:prstGeom>
-          <a:solidFill>
-            <a:srgbClr val="F4F7FB"/>
-          </a:solidFill>
-          <a:ln w="12700">
-            <a:solidFill>
-              <a:srgbClr val="F4F7FB"/>
-            </a:solidFill>
-            <a:prstDash val="solid"/>
-          </a:ln>
-        </p:spPr>
-      </p:sp>
-      <p:sp>
-        <p:nvSpPr>
-          <p:cNvPr id="8" name="Text 6"/>
+              <a:t>BOZ Jewelry  |  Olalekan Ajimoti, Business Analyst portfolio</a:t>
+            </a:r>
+            <a:endParaRPr lang="en-US" sz="900" dirty="0"/>
+          </a:p>
+        </p:txBody>
+      </p:sp>
+      <p:sp>
+        <p:nvSpPr>
+          <p:cNvPr id="11" name="Text 9"/>
           <p:cNvSpPr txBox="1"/>
           <p:nvPr/>
         </p:nvSpPr>
         <p:spPr>
           <a:xfrm>
-            <a:off x="6537960" y="2011680"/>
-            <a:ext cx="4754880" cy="1463040"/>
+            <a:off x="11247120" y="6446520"/>
+            <a:ext cx="548640" cy="274320"/>
           </a:xfrm>
           <a:prstGeom prst="rect">
             <a:avLst/>
@@ -4175,138 +4935,144 @@
           <a:bodyPr wrap="square" lIns="0" tIns="0" rIns="0" bIns="0" rtlCol="0" anchor="ctr"/>
           <a:lstStyle/>
           <a:p>
-            <a:pPr indent="0" marL="0">
+            <a:pPr algn="r" indent="0" marL="0">
               <a:buNone/>
             </a:pPr>
             <a:r>
-              <a:rPr lang="en-US" sz="7200" b="1" dirty="0">
-                <a:solidFill>
-                  <a:srgbClr val="0F766E"/>
+              <a:rPr lang="en-US" sz="900" dirty="0">
+                <a:solidFill>
+                  <a:srgbClr val="64748B"/>
                 </a:solidFill>
                 <a:latin typeface="Arial" pitchFamily="34" charset="0"/>
                 <a:ea typeface="Arial" pitchFamily="34" charset="-122"/>
                 <a:cs typeface="Arial" pitchFamily="34" charset="-120"/>
               </a:rPr>
-              <a:t>25%</a:t>
-            </a:r>
-            <a:endParaRPr lang="en-US" sz="7200" dirty="0"/>
-          </a:p>
-        </p:txBody>
-      </p:sp>
-      <p:sp>
-        <p:nvSpPr>
-          <p:cNvPr id="9" name="Text 7"/>
+              <a:t>06</a:t>
+            </a:r>
+            <a:endParaRPr lang="en-US" sz="900" dirty="0"/>
+          </a:p>
+        </p:txBody>
+      </p:sp>
+      <p:sp>
+        <p:nvSpPr>
+          <p:cNvPr id="12" name="Rectangle 11"/>
+          <p:cNvSpPr/>
+          <p:nvPr/>
+        </p:nvSpPr>
+        <p:spPr>
+          <a:xfrm>
+            <a:off x="0" y="0"/>
+            <a:ext cx="12192000" cy="82296"/>
+          </a:xfrm>
+          <a:prstGeom prst="rect">
+            <a:avLst/>
+          </a:prstGeom>
+          <a:solidFill>
+            <a:srgbClr val="3A2A12"/>
+          </a:solidFill>
+          <a:ln>
+            <a:noFill/>
+          </a:ln>
+          <a:effectLst/>
+        </p:spPr>
+        <p:style>
+          <a:lnRef idx="1">
+            <a:schemeClr val="accent1"/>
+          </a:lnRef>
+          <a:fillRef idx="3">
+            <a:schemeClr val="accent1"/>
+          </a:fillRef>
+          <a:effectRef idx="2">
+            <a:schemeClr val="accent1"/>
+          </a:effectRef>
+          <a:fontRef idx="minor">
+            <a:schemeClr val="lt1"/>
+          </a:fontRef>
+        </p:style>
+        <p:txBody>
+          <a:bodyPr rtlCol="0" anchor="ctr"/>
+          <a:lstStyle/>
+          <a:p>
+            <a:pPr algn="ctr"/>
+          </a:p>
+        </p:txBody>
+      </p:sp>
+      <p:sp>
+        <p:nvSpPr>
+          <p:cNvPr id="13" name="Rectangle 12"/>
+          <p:cNvSpPr/>
+          <p:nvPr/>
+        </p:nvSpPr>
+        <p:spPr>
+          <a:xfrm>
+            <a:off x="0" y="82296"/>
+            <a:ext cx="1463040" cy="45720"/>
+          </a:xfrm>
+          <a:prstGeom prst="rect">
+            <a:avLst/>
+          </a:prstGeom>
+          <a:solidFill>
+            <a:srgbClr val="C9A24A"/>
+          </a:solidFill>
+          <a:ln>
+            <a:noFill/>
+          </a:ln>
+          <a:effectLst/>
+        </p:spPr>
+        <p:style>
+          <a:lnRef idx="1">
+            <a:schemeClr val="accent1"/>
+          </a:lnRef>
+          <a:fillRef idx="3">
+            <a:schemeClr val="accent1"/>
+          </a:fillRef>
+          <a:effectRef idx="2">
+            <a:schemeClr val="accent1"/>
+          </a:effectRef>
+          <a:fontRef idx="minor">
+            <a:schemeClr val="lt1"/>
+          </a:fontRef>
+        </p:style>
+        <p:txBody>
+          <a:bodyPr rtlCol="0" anchor="ctr"/>
+          <a:lstStyle/>
+          <a:p>
+            <a:pPr algn="ctr"/>
+          </a:p>
+        </p:txBody>
+      </p:sp>
+      <p:sp>
+        <p:nvSpPr>
+          <p:cNvPr id="14" name="TextBox 13"/>
           <p:cNvSpPr txBox="1"/>
           <p:nvPr/>
         </p:nvSpPr>
         <p:spPr>
           <a:xfrm>
-            <a:off x="6537960" y="3566160"/>
-            <a:ext cx="4754880" cy="914400"/>
+            <a:off x="10088880" y="6327648"/>
+            <a:ext cx="1463040" cy="384048"/>
           </a:xfrm>
           <a:prstGeom prst="rect">
             <a:avLst/>
           </a:prstGeom>
           <a:noFill/>
-          <a:ln/>
-        </p:spPr>
-        <p:txBody>
-          <a:bodyPr wrap="square" lIns="0" tIns="0" rIns="0" bIns="0" rtlCol="0" anchor="t"/>
-          <a:lstStyle/>
-          <a:p>
-            <a:pPr indent="0" marL="0">
-              <a:buNone/>
-            </a:pPr>
-            <a:r>
-              <a:rPr lang="en-US" sz="1800" dirty="0">
-                <a:solidFill>
-                  <a:srgbClr val="1E293B"/>
-                </a:solidFill>
-                <a:latin typeface="Arial" pitchFamily="34" charset="0"/>
-                <a:ea typeface="Arial" pitchFamily="34" charset="-122"/>
-                <a:cs typeface="Arial" pitchFamily="34" charset="-120"/>
-              </a:rPr>
-              <a:t>uplift in digital performance (reported)</a:t>
-            </a:r>
-            <a:endParaRPr lang="en-US" sz="1800" dirty="0"/>
-          </a:p>
-        </p:txBody>
-      </p:sp>
-      <p:sp>
-        <p:nvSpPr>
-          <p:cNvPr id="10" name="Text 8"/>
-          <p:cNvSpPr txBox="1"/>
-          <p:nvPr/>
-        </p:nvSpPr>
-        <p:spPr>
-          <a:xfrm>
-            <a:off x="457200" y="6446520"/>
-            <a:ext cx="8229600" cy="274320"/>
-          </a:xfrm>
-          <a:prstGeom prst="rect">
-            <a:avLst/>
-          </a:prstGeom>
-          <a:noFill/>
-          <a:ln/>
-        </p:spPr>
-        <p:txBody>
-          <a:bodyPr wrap="square" lIns="0" tIns="0" rIns="0" bIns="0" rtlCol="0" anchor="ctr"/>
-          <a:lstStyle/>
-          <a:p>
-            <a:pPr indent="0" marL="0">
-              <a:buNone/>
-            </a:pPr>
-            <a:r>
-              <a:rPr lang="en-US" sz="900" dirty="0">
-                <a:solidFill>
-                  <a:srgbClr val="64748B"/>
-                </a:solidFill>
-                <a:latin typeface="Arial" pitchFamily="34" charset="0"/>
-                <a:ea typeface="Arial" pitchFamily="34" charset="-122"/>
-                <a:cs typeface="Arial" pitchFamily="34" charset="-120"/>
-              </a:rPr>
-              <a:t>BOZ Jewelry  |  Olalekan Ajimoti, Business Analyst portfolio</a:t>
-            </a:r>
-            <a:endParaRPr lang="en-US" sz="900" dirty="0"/>
-          </a:p>
-        </p:txBody>
-      </p:sp>
-      <p:sp>
-        <p:nvSpPr>
-          <p:cNvPr id="11" name="Text 9"/>
-          <p:cNvSpPr txBox="1"/>
-          <p:nvPr/>
-        </p:nvSpPr>
-        <p:spPr>
-          <a:xfrm>
-            <a:off x="11247120" y="6446520"/>
-            <a:ext cx="548640" cy="274320"/>
-          </a:xfrm>
-          <a:prstGeom prst="rect">
-            <a:avLst/>
-          </a:prstGeom>
-          <a:noFill/>
-          <a:ln/>
-        </p:spPr>
-        <p:txBody>
-          <a:bodyPr wrap="square" lIns="0" tIns="0" rIns="0" bIns="0" rtlCol="0" anchor="ctr"/>
-          <a:lstStyle/>
-          <a:p>
-            <a:pPr algn="r" indent="0" marL="0">
-              <a:buNone/>
-            </a:pPr>
-            <a:r>
-              <a:rPr lang="en-US" sz="900" dirty="0">
-                <a:solidFill>
-                  <a:srgbClr val="64748B"/>
-                </a:solidFill>
-                <a:latin typeface="Arial" pitchFamily="34" charset="0"/>
-                <a:ea typeface="Arial" pitchFamily="34" charset="-122"/>
-                <a:cs typeface="Arial" pitchFamily="34" charset="-120"/>
-              </a:rPr>
-              <a:t>06</a:t>
-            </a:r>
-            <a:endParaRPr lang="en-US" sz="900" dirty="0"/>
+        </p:spPr>
+        <p:txBody>
+          <a:bodyPr wrap="none" anchor="ctr">
+            <a:spAutoFit/>
+          </a:bodyPr>
+          <a:lstStyle/>
+          <a:p>
+            <a:pPr algn="ctr"/>
+            <a:r>
+              <a:rPr sz="1300" b="1">
+                <a:solidFill>
+                  <a:srgbClr val="3A2A12"/>
+                </a:solidFill>
+                <a:latin typeface="Liberation Serif"/>
+              </a:rPr>
+              <a:t>BOZ</a:t>
+            </a:r>
           </a:p>
         </p:txBody>
       </p:sp>
@@ -4369,11 +5135,11 @@
             <a:r>
               <a:rPr lang="en-US" sz="2600" b="1" dirty="0">
                 <a:solidFill>
-                  <a:srgbClr val="15253D"/>
-                </a:solidFill>
-                <a:latin typeface="Arial" pitchFamily="34" charset="0"/>
-                <a:ea typeface="Arial" pitchFamily="34" charset="-122"/>
-                <a:cs typeface="Arial" pitchFamily="34" charset="-120"/>
+                  <a:srgbClr val="3A2A12"/>
+                </a:solidFill>
+                <a:latin typeface="Liberation Serif" pitchFamily="34" charset="0"/>
+                <a:ea typeface="Liberation Serif" pitchFamily="34" charset="-122"/>
+                <a:cs typeface="Liberation Serif" pitchFamily="34" charset="-120"/>
               </a:rPr>
               <a:t>Recommendations and key risks</a:t>
             </a:r>
@@ -4408,7 +5174,7 @@
             <a:r>
               <a:rPr lang="en-US" sz="1500" b="1" dirty="0">
                 <a:solidFill>
-                  <a:srgbClr val="0F766E"/>
+                  <a:srgbClr val="9C7625"/>
                 </a:solidFill>
                 <a:latin typeface="Arial" pitchFamily="34" charset="0"/>
                 <a:ea typeface="Arial" pitchFamily="34" charset="-122"/>
@@ -4553,7 +5319,7 @@
             <a:r>
               <a:rPr lang="en-US" sz="1500" b="1" dirty="0">
                 <a:solidFill>
-                  <a:srgbClr val="EA580C"/>
+                  <a:srgbClr val="C9A24A"/>
                 </a:solidFill>
                 <a:latin typeface="Arial" pitchFamily="34" charset="0"/>
                 <a:ea typeface="Arial" pitchFamily="34" charset="-122"/>
@@ -4580,15 +5346,19 @@
             <a:avLst/>
           </a:prstGeom>
           <a:solidFill>
-            <a:srgbClr val="F4F7FB"/>
+            <a:srgbClr val="FBF8F1"/>
           </a:solidFill>
           <a:ln w="12700">
             <a:solidFill>
-              <a:srgbClr val="F4F7FB"/>
+              <a:srgbClr val="FBF8F1"/>
             </a:solidFill>
             <a:prstDash val="solid"/>
           </a:ln>
         </p:spPr>
+        <p:txBody>
+          <a:bodyPr/>
+          <a:p/>
+        </p:txBody>
       </p:sp>
       <p:sp>
         <p:nvSpPr>
@@ -4724,15 +5494,19 @@
             <a:avLst/>
           </a:prstGeom>
           <a:solidFill>
-            <a:srgbClr val="F4F7FB"/>
+            <a:srgbClr val="FBF8F1"/>
           </a:solidFill>
           <a:ln w="12700">
             <a:solidFill>
-              <a:srgbClr val="F4F7FB"/>
+              <a:srgbClr val="FBF8F1"/>
             </a:solidFill>
             <a:prstDash val="solid"/>
           </a:ln>
         </p:spPr>
+        <p:txBody>
+          <a:bodyPr/>
+          <a:p/>
+        </p:txBody>
       </p:sp>
       <p:sp>
         <p:nvSpPr>
@@ -4868,15 +5642,19 @@
             <a:avLst/>
           </a:prstGeom>
           <a:solidFill>
-            <a:srgbClr val="F4F7FB"/>
+            <a:srgbClr val="FBF8F1"/>
           </a:solidFill>
           <a:ln w="12700">
             <a:solidFill>
-              <a:srgbClr val="F4F7FB"/>
+              <a:srgbClr val="FBF8F1"/>
             </a:solidFill>
             <a:prstDash val="solid"/>
           </a:ln>
         </p:spPr>
+        <p:txBody>
+          <a:bodyPr/>
+          <a:p/>
+        </p:txBody>
       </p:sp>
       <p:sp>
         <p:nvSpPr>
@@ -5012,15 +5790,19 @@
             <a:avLst/>
           </a:prstGeom>
           <a:solidFill>
-            <a:srgbClr val="F4F7FB"/>
+            <a:srgbClr val="FBF8F1"/>
           </a:solidFill>
           <a:ln w="12700">
             <a:solidFill>
-              <a:srgbClr val="F4F7FB"/>
+              <a:srgbClr val="FBF8F1"/>
             </a:solidFill>
             <a:prstDash val="solid"/>
           </a:ln>
         </p:spPr>
+        <p:txBody>
+          <a:bodyPr/>
+          <a:p/>
+        </p:txBody>
       </p:sp>
       <p:sp>
         <p:nvSpPr>
@@ -5216,6 +5998,129 @@
               <a:t>07</a:t>
             </a:r>
             <a:endParaRPr lang="en-US" sz="900" dirty="0"/>
+          </a:p>
+        </p:txBody>
+      </p:sp>
+      <p:sp>
+        <p:nvSpPr>
+          <p:cNvPr id="24" name="Rectangle 23"/>
+          <p:cNvSpPr/>
+          <p:nvPr/>
+        </p:nvSpPr>
+        <p:spPr>
+          <a:xfrm>
+            <a:off x="0" y="0"/>
+            <a:ext cx="12192000" cy="82296"/>
+          </a:xfrm>
+          <a:prstGeom prst="rect">
+            <a:avLst/>
+          </a:prstGeom>
+          <a:solidFill>
+            <a:srgbClr val="3A2A12"/>
+          </a:solidFill>
+          <a:ln>
+            <a:noFill/>
+          </a:ln>
+          <a:effectLst/>
+        </p:spPr>
+        <p:style>
+          <a:lnRef idx="1">
+            <a:schemeClr val="accent1"/>
+          </a:lnRef>
+          <a:fillRef idx="3">
+            <a:schemeClr val="accent1"/>
+          </a:fillRef>
+          <a:effectRef idx="2">
+            <a:schemeClr val="accent1"/>
+          </a:effectRef>
+          <a:fontRef idx="minor">
+            <a:schemeClr val="lt1"/>
+          </a:fontRef>
+        </p:style>
+        <p:txBody>
+          <a:bodyPr rtlCol="0" anchor="ctr"/>
+          <a:lstStyle/>
+          <a:p>
+            <a:pPr algn="ctr"/>
+          </a:p>
+        </p:txBody>
+      </p:sp>
+      <p:sp>
+        <p:nvSpPr>
+          <p:cNvPr id="25" name="Rectangle 24"/>
+          <p:cNvSpPr/>
+          <p:nvPr/>
+        </p:nvSpPr>
+        <p:spPr>
+          <a:xfrm>
+            <a:off x="0" y="82296"/>
+            <a:ext cx="1463040" cy="45720"/>
+          </a:xfrm>
+          <a:prstGeom prst="rect">
+            <a:avLst/>
+          </a:prstGeom>
+          <a:solidFill>
+            <a:srgbClr val="C9A24A"/>
+          </a:solidFill>
+          <a:ln>
+            <a:noFill/>
+          </a:ln>
+          <a:effectLst/>
+        </p:spPr>
+        <p:style>
+          <a:lnRef idx="1">
+            <a:schemeClr val="accent1"/>
+          </a:lnRef>
+          <a:fillRef idx="3">
+            <a:schemeClr val="accent1"/>
+          </a:fillRef>
+          <a:effectRef idx="2">
+            <a:schemeClr val="accent1"/>
+          </a:effectRef>
+          <a:fontRef idx="minor">
+            <a:schemeClr val="lt1"/>
+          </a:fontRef>
+        </p:style>
+        <p:txBody>
+          <a:bodyPr rtlCol="0" anchor="ctr"/>
+          <a:lstStyle/>
+          <a:p>
+            <a:pPr algn="ctr"/>
+          </a:p>
+        </p:txBody>
+      </p:sp>
+      <p:sp>
+        <p:nvSpPr>
+          <p:cNvPr id="26" name="TextBox 25"/>
+          <p:cNvSpPr txBox="1"/>
+          <p:nvPr/>
+        </p:nvSpPr>
+        <p:spPr>
+          <a:xfrm>
+            <a:off x="10088880" y="6327648"/>
+            <a:ext cx="1463040" cy="384048"/>
+          </a:xfrm>
+          <a:prstGeom prst="rect">
+            <a:avLst/>
+          </a:prstGeom>
+          <a:noFill/>
+        </p:spPr>
+        <p:txBody>
+          <a:bodyPr wrap="none" anchor="ctr">
+            <a:spAutoFit/>
+          </a:bodyPr>
+          <a:lstStyle/>
+          <a:p>
+            <a:pPr algn="ctr"/>
+            <a:r>
+              <a:rPr sz="1300" b="1">
+                <a:solidFill>
+                  <a:srgbClr val="3A2A12"/>
+                </a:solidFill>
+                <a:latin typeface="Liberation Serif"/>
+              </a:rPr>
+              <a:t>BOZ</a:t>
+            </a:r>
           </a:p>
         </p:txBody>
       </p:sp>

</xml_diff>